<commit_message>
Push slide con cambiamenti
</commit_message>
<xml_diff>
--- a/speed_monitoring.pptx
+++ b/speed_monitoring.pptx
@@ -736,6 +736,935 @@
           <a:p>
             <a:endParaRPr lang="en-US" dirty="0"/>
           </a:p>
+          <a:p>
+            <a:r>
+              <a:rPr lang="en-GB" sz="1200" kern="1200" dirty="0">
+                <a:solidFill>
+                  <a:schemeClr val="tx1"/>
+                </a:solidFill>
+                <a:effectLst/>
+                <a:latin typeface="+mn-lt"/>
+                <a:ea typeface="+mn-ea"/>
+                <a:cs typeface="+mn-cs"/>
+              </a:rPr>
+              <a:t>Il </a:t>
+            </a:r>
+            <a:r>
+              <a:rPr lang="en-GB" sz="1200" kern="1200" dirty="0" err="1">
+                <a:solidFill>
+                  <a:schemeClr val="tx1"/>
+                </a:solidFill>
+                <a:effectLst/>
+                <a:latin typeface="+mn-lt"/>
+                <a:ea typeface="+mn-ea"/>
+                <a:cs typeface="+mn-cs"/>
+              </a:rPr>
+              <a:t>grafico</a:t>
+            </a:r>
+            <a:r>
+              <a:rPr lang="en-GB" sz="1200" kern="1200" dirty="0">
+                <a:solidFill>
+                  <a:schemeClr val="tx1"/>
+                </a:solidFill>
+                <a:effectLst/>
+                <a:latin typeface="+mn-lt"/>
+                <a:ea typeface="+mn-ea"/>
+                <a:cs typeface="+mn-cs"/>
+              </a:rPr>
+              <a:t> </a:t>
+            </a:r>
+            <a:r>
+              <a:rPr lang="en-GB" sz="1200" kern="1200" dirty="0" err="1">
+                <a:solidFill>
+                  <a:schemeClr val="tx1"/>
+                </a:solidFill>
+                <a:effectLst/>
+                <a:latin typeface="+mn-lt"/>
+                <a:ea typeface="+mn-ea"/>
+                <a:cs typeface="+mn-cs"/>
+              </a:rPr>
+              <a:t>dimostra</a:t>
+            </a:r>
+            <a:r>
+              <a:rPr lang="en-GB" sz="1200" kern="1200" dirty="0">
+                <a:solidFill>
+                  <a:schemeClr val="tx1"/>
+                </a:solidFill>
+                <a:effectLst/>
+                <a:latin typeface="+mn-lt"/>
+                <a:ea typeface="+mn-ea"/>
+                <a:cs typeface="+mn-cs"/>
+              </a:rPr>
+              <a:t> </a:t>
+            </a:r>
+            <a:r>
+              <a:rPr lang="en-GB" sz="1200" kern="1200" dirty="0" err="1">
+                <a:solidFill>
+                  <a:schemeClr val="tx1"/>
+                </a:solidFill>
+                <a:effectLst/>
+                <a:latin typeface="+mn-lt"/>
+                <a:ea typeface="+mn-ea"/>
+                <a:cs typeface="+mn-cs"/>
+              </a:rPr>
+              <a:t>un'inosservanza</a:t>
+            </a:r>
+            <a:r>
+              <a:rPr lang="en-GB" sz="1200" kern="1200" dirty="0">
+                <a:solidFill>
+                  <a:schemeClr val="tx1"/>
+                </a:solidFill>
+                <a:effectLst/>
+                <a:latin typeface="+mn-lt"/>
+                <a:ea typeface="+mn-ea"/>
+                <a:cs typeface="+mn-cs"/>
+              </a:rPr>
+              <a:t> </a:t>
+            </a:r>
+            <a:r>
+              <a:rPr lang="en-GB" sz="1200" kern="1200" dirty="0" err="1">
+                <a:solidFill>
+                  <a:schemeClr val="tx1"/>
+                </a:solidFill>
+                <a:effectLst/>
+                <a:latin typeface="+mn-lt"/>
+                <a:ea typeface="+mn-ea"/>
+                <a:cs typeface="+mn-cs"/>
+              </a:rPr>
+              <a:t>sistematica</a:t>
+            </a:r>
+            <a:r>
+              <a:rPr lang="en-GB" sz="1200" kern="1200" dirty="0">
+                <a:solidFill>
+                  <a:schemeClr val="tx1"/>
+                </a:solidFill>
+                <a:effectLst/>
+                <a:latin typeface="+mn-lt"/>
+                <a:ea typeface="+mn-ea"/>
+                <a:cs typeface="+mn-cs"/>
+              </a:rPr>
+              <a:t> e di </a:t>
+            </a:r>
+            <a:r>
+              <a:rPr lang="en-GB" sz="1200" kern="1200" dirty="0" err="1">
+                <a:solidFill>
+                  <a:schemeClr val="tx1"/>
+                </a:solidFill>
+                <a:effectLst/>
+                <a:latin typeface="+mn-lt"/>
+                <a:ea typeface="+mn-ea"/>
+                <a:cs typeface="+mn-cs"/>
+              </a:rPr>
+              <a:t>massa</a:t>
+            </a:r>
+            <a:r>
+              <a:rPr lang="en-GB" sz="1200" kern="1200" dirty="0">
+                <a:solidFill>
+                  <a:schemeClr val="tx1"/>
+                </a:solidFill>
+                <a:effectLst/>
+                <a:latin typeface="+mn-lt"/>
+                <a:ea typeface="+mn-ea"/>
+                <a:cs typeface="+mn-cs"/>
+              </a:rPr>
+              <a:t> del </a:t>
+            </a:r>
+            <a:r>
+              <a:rPr lang="en-GB" sz="1200" kern="1200" dirty="0" err="1">
+                <a:solidFill>
+                  <a:schemeClr val="tx1"/>
+                </a:solidFill>
+                <a:effectLst/>
+                <a:latin typeface="+mn-lt"/>
+                <a:ea typeface="+mn-ea"/>
+                <a:cs typeface="+mn-cs"/>
+              </a:rPr>
+              <a:t>limite</a:t>
+            </a:r>
+            <a:r>
+              <a:rPr lang="en-GB" sz="1200" kern="1200" dirty="0">
+                <a:solidFill>
+                  <a:schemeClr val="tx1"/>
+                </a:solidFill>
+                <a:effectLst/>
+                <a:latin typeface="+mn-lt"/>
+                <a:ea typeface="+mn-ea"/>
+                <a:cs typeface="+mn-cs"/>
+              </a:rPr>
+              <a:t> di </a:t>
+            </a:r>
+            <a:r>
+              <a:rPr lang="en-GB" sz="1200" kern="1200" dirty="0" err="1">
+                <a:solidFill>
+                  <a:schemeClr val="tx1"/>
+                </a:solidFill>
+                <a:effectLst/>
+                <a:latin typeface="+mn-lt"/>
+                <a:ea typeface="+mn-ea"/>
+                <a:cs typeface="+mn-cs"/>
+              </a:rPr>
+              <a:t>velocità</a:t>
+            </a:r>
+            <a:r>
+              <a:rPr lang="en-GB" sz="1200" kern="1200" dirty="0">
+                <a:solidFill>
+                  <a:schemeClr val="tx1"/>
+                </a:solidFill>
+                <a:effectLst/>
+                <a:latin typeface="+mn-lt"/>
+                <a:ea typeface="+mn-ea"/>
+                <a:cs typeface="+mn-cs"/>
+              </a:rPr>
+              <a:t> </a:t>
+            </a:r>
+            <a:r>
+              <a:rPr lang="en-GB" sz="1200" kern="1200" dirty="0" err="1">
+                <a:solidFill>
+                  <a:schemeClr val="tx1"/>
+                </a:solidFill>
+                <a:effectLst/>
+                <a:latin typeface="+mn-lt"/>
+                <a:ea typeface="+mn-ea"/>
+                <a:cs typeface="+mn-cs"/>
+              </a:rPr>
+              <a:t>presso</a:t>
+            </a:r>
+            <a:r>
+              <a:rPr lang="en-GB" sz="1200" kern="1200" dirty="0">
+                <a:solidFill>
+                  <a:schemeClr val="tx1"/>
+                </a:solidFill>
+                <a:effectLst/>
+                <a:latin typeface="+mn-lt"/>
+                <a:ea typeface="+mn-ea"/>
+                <a:cs typeface="+mn-cs"/>
+              </a:rPr>
+              <a:t> la </a:t>
+            </a:r>
+            <a:r>
+              <a:rPr lang="en-GB" sz="1200" kern="1200" dirty="0" err="1">
+                <a:solidFill>
+                  <a:schemeClr val="tx1"/>
+                </a:solidFill>
+                <a:effectLst/>
+                <a:latin typeface="+mn-lt"/>
+                <a:ea typeface="+mn-ea"/>
+                <a:cs typeface="+mn-cs"/>
+              </a:rPr>
+              <a:t>postazione</a:t>
+            </a:r>
+            <a:r>
+              <a:rPr lang="en-GB" sz="1200" kern="1200" dirty="0">
+                <a:solidFill>
+                  <a:schemeClr val="tx1"/>
+                </a:solidFill>
+                <a:effectLst/>
+                <a:latin typeface="+mn-lt"/>
+                <a:ea typeface="+mn-ea"/>
+                <a:cs typeface="+mn-cs"/>
+              </a:rPr>
+              <a:t> "A2 </a:t>
+            </a:r>
+            <a:r>
+              <a:rPr lang="en-GB" sz="1200" kern="1200" dirty="0" err="1">
+                <a:solidFill>
+                  <a:schemeClr val="tx1"/>
+                </a:solidFill>
+                <a:effectLst/>
+                <a:latin typeface="+mn-lt"/>
+                <a:ea typeface="+mn-ea"/>
+                <a:cs typeface="+mn-cs"/>
+              </a:rPr>
+              <a:t>Einfahrt</a:t>
+            </a:r>
+            <a:r>
+              <a:rPr lang="en-GB" sz="1200" kern="1200" dirty="0">
+                <a:solidFill>
+                  <a:schemeClr val="tx1"/>
+                </a:solidFill>
+                <a:effectLst/>
+                <a:latin typeface="+mn-lt"/>
+                <a:ea typeface="+mn-ea"/>
+                <a:cs typeface="+mn-cs"/>
+              </a:rPr>
+              <a:t> Wolf".</a:t>
+            </a:r>
+            <a:br>
+              <a:rPr lang="en-GB" sz="1200" kern="1200" dirty="0">
+                <a:solidFill>
+                  <a:schemeClr val="tx1"/>
+                </a:solidFill>
+                <a:effectLst/>
+                <a:latin typeface="+mn-lt"/>
+                <a:ea typeface="+mn-ea"/>
+                <a:cs typeface="+mn-cs"/>
+              </a:rPr>
+            </a:br>
+            <a:r>
+              <a:rPr lang="en-GB" sz="1200" kern="1200" dirty="0">
+                <a:solidFill>
+                  <a:schemeClr val="tx1"/>
+                </a:solidFill>
+                <a:effectLst/>
+                <a:latin typeface="+mn-lt"/>
+                <a:ea typeface="+mn-ea"/>
+                <a:cs typeface="+mn-cs"/>
+              </a:rPr>
+              <a:t>La "campana" della </a:t>
+            </a:r>
+            <a:r>
+              <a:rPr lang="en-GB" sz="1200" kern="1200" dirty="0" err="1">
+                <a:solidFill>
+                  <a:schemeClr val="tx1"/>
+                </a:solidFill>
+                <a:effectLst/>
+                <a:latin typeface="+mn-lt"/>
+                <a:ea typeface="+mn-ea"/>
+                <a:cs typeface="+mn-cs"/>
+              </a:rPr>
+              <a:t>distribuzione</a:t>
+            </a:r>
+            <a:r>
+              <a:rPr lang="en-GB" sz="1200" kern="1200" dirty="0">
+                <a:solidFill>
+                  <a:schemeClr val="tx1"/>
+                </a:solidFill>
+                <a:effectLst/>
+                <a:latin typeface="+mn-lt"/>
+                <a:ea typeface="+mn-ea"/>
+                <a:cs typeface="+mn-cs"/>
+              </a:rPr>
+              <a:t> </a:t>
+            </a:r>
+            <a:r>
+              <a:rPr lang="en-GB" sz="1200" kern="1200" dirty="0" err="1">
+                <a:solidFill>
+                  <a:schemeClr val="tx1"/>
+                </a:solidFill>
+                <a:effectLst/>
+                <a:latin typeface="+mn-lt"/>
+                <a:ea typeface="+mn-ea"/>
+                <a:cs typeface="+mn-cs"/>
+              </a:rPr>
+              <a:t>è</a:t>
+            </a:r>
+            <a:r>
+              <a:rPr lang="en-GB" sz="1200" kern="1200" dirty="0">
+                <a:solidFill>
+                  <a:schemeClr val="tx1"/>
+                </a:solidFill>
+                <a:effectLst/>
+                <a:latin typeface="+mn-lt"/>
+                <a:ea typeface="+mn-ea"/>
+                <a:cs typeface="+mn-cs"/>
+              </a:rPr>
+              <a:t> </a:t>
+            </a:r>
+            <a:r>
+              <a:rPr lang="en-GB" sz="1200" kern="1200" dirty="0" err="1">
+                <a:solidFill>
+                  <a:schemeClr val="tx1"/>
+                </a:solidFill>
+                <a:effectLst/>
+                <a:latin typeface="+mn-lt"/>
+                <a:ea typeface="+mn-ea"/>
+                <a:cs typeface="+mn-cs"/>
+              </a:rPr>
+              <a:t>nettamente</a:t>
+            </a:r>
+            <a:r>
+              <a:rPr lang="en-GB" sz="1200" kern="1200" dirty="0">
+                <a:solidFill>
+                  <a:schemeClr val="tx1"/>
+                </a:solidFill>
+                <a:effectLst/>
+                <a:latin typeface="+mn-lt"/>
+                <a:ea typeface="+mn-ea"/>
+                <a:cs typeface="+mn-cs"/>
+              </a:rPr>
+              <a:t> </a:t>
+            </a:r>
+            <a:r>
+              <a:rPr lang="en-GB" sz="1200" kern="1200" dirty="0" err="1">
+                <a:solidFill>
+                  <a:schemeClr val="tx1"/>
+                </a:solidFill>
+                <a:effectLst/>
+                <a:latin typeface="+mn-lt"/>
+                <a:ea typeface="+mn-ea"/>
+                <a:cs typeface="+mn-cs"/>
+              </a:rPr>
+              <a:t>spostata</a:t>
+            </a:r>
+            <a:r>
+              <a:rPr lang="en-GB" sz="1200" kern="1200" dirty="0">
+                <a:solidFill>
+                  <a:schemeClr val="tx1"/>
+                </a:solidFill>
+                <a:effectLst/>
+                <a:latin typeface="+mn-lt"/>
+                <a:ea typeface="+mn-ea"/>
+                <a:cs typeface="+mn-cs"/>
+              </a:rPr>
+              <a:t> a </a:t>
+            </a:r>
+            <a:r>
+              <a:rPr lang="en-GB" sz="1200" kern="1200" dirty="0" err="1">
+                <a:solidFill>
+                  <a:schemeClr val="tx1"/>
+                </a:solidFill>
+                <a:effectLst/>
+                <a:latin typeface="+mn-lt"/>
+                <a:ea typeface="+mn-ea"/>
+                <a:cs typeface="+mn-cs"/>
+              </a:rPr>
+              <a:t>destra</a:t>
+            </a:r>
+            <a:r>
+              <a:rPr lang="en-GB" sz="1200" kern="1200" dirty="0">
+                <a:solidFill>
+                  <a:schemeClr val="tx1"/>
+                </a:solidFill>
+                <a:effectLst/>
+                <a:latin typeface="+mn-lt"/>
+                <a:ea typeface="+mn-ea"/>
+                <a:cs typeface="+mn-cs"/>
+              </a:rPr>
+              <a:t> rispetto alla </a:t>
+            </a:r>
+            <a:r>
+              <a:rPr lang="en-GB" sz="1200" kern="1200" dirty="0" err="1">
+                <a:solidFill>
+                  <a:schemeClr val="tx1"/>
+                </a:solidFill>
+                <a:effectLst/>
+                <a:latin typeface="+mn-lt"/>
+                <a:ea typeface="+mn-ea"/>
+                <a:cs typeface="+mn-cs"/>
+              </a:rPr>
+              <a:t>linea</a:t>
+            </a:r>
+            <a:r>
+              <a:rPr lang="en-GB" sz="1200" kern="1200" dirty="0">
+                <a:solidFill>
+                  <a:schemeClr val="tx1"/>
+                </a:solidFill>
+                <a:effectLst/>
+                <a:latin typeface="+mn-lt"/>
+                <a:ea typeface="+mn-ea"/>
+                <a:cs typeface="+mn-cs"/>
+              </a:rPr>
+              <a:t> </a:t>
+            </a:r>
+            <a:r>
+              <a:rPr lang="en-GB" sz="1200" kern="1200" dirty="0" err="1">
+                <a:solidFill>
+                  <a:schemeClr val="tx1"/>
+                </a:solidFill>
+                <a:effectLst/>
+                <a:latin typeface="+mn-lt"/>
+                <a:ea typeface="+mn-ea"/>
+                <a:cs typeface="+mn-cs"/>
+              </a:rPr>
+              <a:t>rossa</a:t>
+            </a:r>
+            <a:r>
+              <a:rPr lang="en-GB" sz="1200" kern="1200" dirty="0">
+                <a:solidFill>
+                  <a:schemeClr val="tx1"/>
+                </a:solidFill>
+                <a:effectLst/>
+                <a:latin typeface="+mn-lt"/>
+                <a:ea typeface="+mn-ea"/>
+                <a:cs typeface="+mn-cs"/>
+              </a:rPr>
+              <a:t> del </a:t>
+            </a:r>
+            <a:r>
+              <a:rPr lang="en-GB" sz="1200" kern="1200" dirty="0" err="1">
+                <a:solidFill>
+                  <a:schemeClr val="tx1"/>
+                </a:solidFill>
+                <a:effectLst/>
+                <a:latin typeface="+mn-lt"/>
+                <a:ea typeface="+mn-ea"/>
+                <a:cs typeface="+mn-cs"/>
+              </a:rPr>
+              <a:t>limite</a:t>
+            </a:r>
+            <a:r>
+              <a:rPr lang="en-GB" sz="1200" kern="1200" dirty="0">
+                <a:solidFill>
+                  <a:schemeClr val="tx1"/>
+                </a:solidFill>
+                <a:effectLst/>
+                <a:latin typeface="+mn-lt"/>
+                <a:ea typeface="+mn-ea"/>
+                <a:cs typeface="+mn-cs"/>
+              </a:rPr>
+              <a:t> (40 km/h): la </a:t>
+            </a:r>
+            <a:r>
+              <a:rPr lang="en-GB" sz="1200" kern="1200" dirty="0" err="1">
+                <a:solidFill>
+                  <a:schemeClr val="tx1"/>
+                </a:solidFill>
+                <a:effectLst/>
+                <a:latin typeface="+mn-lt"/>
+                <a:ea typeface="+mn-ea"/>
+                <a:cs typeface="+mn-cs"/>
+              </a:rPr>
+              <a:t>stragrande</a:t>
+            </a:r>
+            <a:r>
+              <a:rPr lang="en-GB" sz="1200" kern="1200" dirty="0">
+                <a:solidFill>
+                  <a:schemeClr val="tx1"/>
+                </a:solidFill>
+                <a:effectLst/>
+                <a:latin typeface="+mn-lt"/>
+                <a:ea typeface="+mn-ea"/>
+                <a:cs typeface="+mn-cs"/>
+              </a:rPr>
+              <a:t> </a:t>
+            </a:r>
+            <a:r>
+              <a:rPr lang="en-GB" sz="1200" kern="1200" dirty="0" err="1">
+                <a:solidFill>
+                  <a:schemeClr val="tx1"/>
+                </a:solidFill>
+                <a:effectLst/>
+                <a:latin typeface="+mn-lt"/>
+                <a:ea typeface="+mn-ea"/>
+                <a:cs typeface="+mn-cs"/>
+              </a:rPr>
+              <a:t>maggioranza</a:t>
+            </a:r>
+            <a:r>
+              <a:rPr lang="en-GB" sz="1200" kern="1200" dirty="0">
+                <a:solidFill>
+                  <a:schemeClr val="tx1"/>
+                </a:solidFill>
+                <a:effectLst/>
+                <a:latin typeface="+mn-lt"/>
+                <a:ea typeface="+mn-ea"/>
+                <a:cs typeface="+mn-cs"/>
+              </a:rPr>
+              <a:t> </a:t>
+            </a:r>
+            <a:r>
+              <a:rPr lang="en-GB" sz="1200" kern="1200" dirty="0" err="1">
+                <a:solidFill>
+                  <a:schemeClr val="tx1"/>
+                </a:solidFill>
+                <a:effectLst/>
+                <a:latin typeface="+mn-lt"/>
+                <a:ea typeface="+mn-ea"/>
+                <a:cs typeface="+mn-cs"/>
+              </a:rPr>
+              <a:t>dei</a:t>
+            </a:r>
+            <a:r>
+              <a:rPr lang="en-GB" sz="1200" kern="1200" dirty="0">
+                <a:solidFill>
+                  <a:schemeClr val="tx1"/>
+                </a:solidFill>
+                <a:effectLst/>
+                <a:latin typeface="+mn-lt"/>
+                <a:ea typeface="+mn-ea"/>
+                <a:cs typeface="+mn-cs"/>
+              </a:rPr>
+              <a:t> </a:t>
+            </a:r>
+            <a:r>
+              <a:rPr lang="en-GB" sz="1200" kern="1200" dirty="0" err="1">
+                <a:solidFill>
+                  <a:schemeClr val="tx1"/>
+                </a:solidFill>
+                <a:effectLst/>
+                <a:latin typeface="+mn-lt"/>
+                <a:ea typeface="+mn-ea"/>
+                <a:cs typeface="+mn-cs"/>
+              </a:rPr>
+              <a:t>veicoli</a:t>
+            </a:r>
+            <a:r>
+              <a:rPr lang="en-GB" sz="1200" kern="1200" dirty="0">
+                <a:solidFill>
+                  <a:schemeClr val="tx1"/>
+                </a:solidFill>
+                <a:effectLst/>
+                <a:latin typeface="+mn-lt"/>
+                <a:ea typeface="+mn-ea"/>
+                <a:cs typeface="+mn-cs"/>
+              </a:rPr>
+              <a:t> </a:t>
+            </a:r>
+            <a:r>
+              <a:rPr lang="en-GB" sz="1200" kern="1200" dirty="0" err="1">
+                <a:solidFill>
+                  <a:schemeClr val="tx1"/>
+                </a:solidFill>
+                <a:effectLst/>
+                <a:latin typeface="+mn-lt"/>
+                <a:ea typeface="+mn-ea"/>
+                <a:cs typeface="+mn-cs"/>
+              </a:rPr>
+              <a:t>viaggia</a:t>
+            </a:r>
+            <a:r>
+              <a:rPr lang="en-GB" sz="1200" kern="1200" dirty="0">
+                <a:solidFill>
+                  <a:schemeClr val="tx1"/>
+                </a:solidFill>
+                <a:effectLst/>
+                <a:latin typeface="+mn-lt"/>
+                <a:ea typeface="+mn-ea"/>
+                <a:cs typeface="+mn-cs"/>
+              </a:rPr>
+              <a:t> </a:t>
+            </a:r>
+            <a:r>
+              <a:rPr lang="en-GB" sz="1200" kern="1200" dirty="0" err="1">
+                <a:solidFill>
+                  <a:schemeClr val="tx1"/>
+                </a:solidFill>
+                <a:effectLst/>
+                <a:latin typeface="+mn-lt"/>
+                <a:ea typeface="+mn-ea"/>
+                <a:cs typeface="+mn-cs"/>
+              </a:rPr>
+              <a:t>tra</a:t>
+            </a:r>
+            <a:r>
+              <a:rPr lang="en-GB" sz="1200" kern="1200" dirty="0">
+                <a:solidFill>
+                  <a:schemeClr val="tx1"/>
+                </a:solidFill>
+                <a:effectLst/>
+                <a:latin typeface="+mn-lt"/>
+                <a:ea typeface="+mn-ea"/>
+                <a:cs typeface="+mn-cs"/>
+              </a:rPr>
+              <a:t> </a:t>
+            </a:r>
+            <a:r>
+              <a:rPr lang="en-GB" sz="1200" kern="1200" dirty="0" err="1">
+                <a:solidFill>
+                  <a:schemeClr val="tx1"/>
+                </a:solidFill>
+                <a:effectLst/>
+                <a:latin typeface="+mn-lt"/>
+                <a:ea typeface="+mn-ea"/>
+                <a:cs typeface="+mn-cs"/>
+              </a:rPr>
+              <a:t>i</a:t>
+            </a:r>
+            <a:r>
+              <a:rPr lang="en-GB" sz="1200" kern="1200" dirty="0">
+                <a:solidFill>
+                  <a:schemeClr val="tx1"/>
+                </a:solidFill>
+                <a:effectLst/>
+                <a:latin typeface="+mn-lt"/>
+                <a:ea typeface="+mn-ea"/>
+                <a:cs typeface="+mn-cs"/>
+              </a:rPr>
+              <a:t> 45 e </a:t>
+            </a:r>
+            <a:r>
+              <a:rPr lang="en-GB" sz="1200" kern="1200" dirty="0" err="1">
+                <a:solidFill>
+                  <a:schemeClr val="tx1"/>
+                </a:solidFill>
+                <a:effectLst/>
+                <a:latin typeface="+mn-lt"/>
+                <a:ea typeface="+mn-ea"/>
+                <a:cs typeface="+mn-cs"/>
+              </a:rPr>
+              <a:t>i</a:t>
+            </a:r>
+            <a:r>
+              <a:rPr lang="en-GB" sz="1200" kern="1200" dirty="0">
+                <a:solidFill>
+                  <a:schemeClr val="tx1"/>
+                </a:solidFill>
+                <a:effectLst/>
+                <a:latin typeface="+mn-lt"/>
+                <a:ea typeface="+mn-ea"/>
+                <a:cs typeface="+mn-cs"/>
+              </a:rPr>
+              <a:t> 55 km/h. </a:t>
+            </a:r>
+            <a:r>
+              <a:rPr lang="en-GB" sz="1200" kern="1200" dirty="0" err="1">
+                <a:solidFill>
+                  <a:schemeClr val="tx1"/>
+                </a:solidFill>
+                <a:effectLst/>
+                <a:latin typeface="+mn-lt"/>
+                <a:ea typeface="+mn-ea"/>
+                <a:cs typeface="+mn-cs"/>
+              </a:rPr>
+              <a:t>Questo</a:t>
+            </a:r>
+            <a:r>
+              <a:rPr lang="en-GB" sz="1200" kern="1200" dirty="0">
+                <a:solidFill>
+                  <a:schemeClr val="tx1"/>
+                </a:solidFill>
+                <a:effectLst/>
+                <a:latin typeface="+mn-lt"/>
+                <a:ea typeface="+mn-ea"/>
+                <a:cs typeface="+mn-cs"/>
+              </a:rPr>
+              <a:t> indica </a:t>
+            </a:r>
+            <a:r>
+              <a:rPr lang="en-GB" sz="1200" kern="1200" dirty="0" err="1">
+                <a:solidFill>
+                  <a:schemeClr val="tx1"/>
+                </a:solidFill>
+                <a:effectLst/>
+                <a:latin typeface="+mn-lt"/>
+                <a:ea typeface="+mn-ea"/>
+                <a:cs typeface="+mn-cs"/>
+              </a:rPr>
+              <a:t>che</a:t>
+            </a:r>
+            <a:r>
+              <a:rPr lang="en-GB" sz="1200" kern="1200" dirty="0">
+                <a:solidFill>
+                  <a:schemeClr val="tx1"/>
+                </a:solidFill>
+                <a:effectLst/>
+                <a:latin typeface="+mn-lt"/>
+                <a:ea typeface="+mn-ea"/>
+                <a:cs typeface="+mn-cs"/>
+              </a:rPr>
+              <a:t> in </a:t>
+            </a:r>
+            <a:r>
+              <a:rPr lang="en-GB" sz="1200" kern="1200" dirty="0" err="1">
+                <a:solidFill>
+                  <a:schemeClr val="tx1"/>
+                </a:solidFill>
+                <a:effectLst/>
+                <a:latin typeface="+mn-lt"/>
+                <a:ea typeface="+mn-ea"/>
+                <a:cs typeface="+mn-cs"/>
+              </a:rPr>
+              <a:t>quel</a:t>
+            </a:r>
+            <a:r>
+              <a:rPr lang="en-GB" sz="1200" kern="1200" dirty="0">
+                <a:solidFill>
+                  <a:schemeClr val="tx1"/>
+                </a:solidFill>
+                <a:effectLst/>
+                <a:latin typeface="+mn-lt"/>
+                <a:ea typeface="+mn-ea"/>
+                <a:cs typeface="+mn-cs"/>
+              </a:rPr>
+              <a:t> </a:t>
+            </a:r>
+            <a:r>
+              <a:rPr lang="en-GB" sz="1200" kern="1200" dirty="0" err="1">
+                <a:solidFill>
+                  <a:schemeClr val="tx1"/>
+                </a:solidFill>
+                <a:effectLst/>
+                <a:latin typeface="+mn-lt"/>
+                <a:ea typeface="+mn-ea"/>
+                <a:cs typeface="+mn-cs"/>
+              </a:rPr>
+              <a:t>tratto</a:t>
+            </a:r>
+            <a:r>
+              <a:rPr lang="en-GB" sz="1200" kern="1200" dirty="0">
+                <a:solidFill>
+                  <a:schemeClr val="tx1"/>
+                </a:solidFill>
+                <a:effectLst/>
+                <a:latin typeface="+mn-lt"/>
+                <a:ea typeface="+mn-ea"/>
+                <a:cs typeface="+mn-cs"/>
+              </a:rPr>
+              <a:t> </a:t>
+            </a:r>
+            <a:r>
+              <a:rPr lang="en-GB" sz="1200" kern="1200" dirty="0" err="1">
+                <a:solidFill>
+                  <a:schemeClr val="tx1"/>
+                </a:solidFill>
+                <a:effectLst/>
+                <a:latin typeface="+mn-lt"/>
+                <a:ea typeface="+mn-ea"/>
+                <a:cs typeface="+mn-cs"/>
+              </a:rPr>
+              <a:t>l'eccesso</a:t>
+            </a:r>
+            <a:r>
+              <a:rPr lang="en-GB" sz="1200" kern="1200" dirty="0">
+                <a:solidFill>
+                  <a:schemeClr val="tx1"/>
+                </a:solidFill>
+                <a:effectLst/>
+                <a:latin typeface="+mn-lt"/>
+                <a:ea typeface="+mn-ea"/>
+                <a:cs typeface="+mn-cs"/>
+              </a:rPr>
+              <a:t> di </a:t>
+            </a:r>
+            <a:r>
+              <a:rPr lang="en-GB" sz="1200" kern="1200" dirty="0" err="1">
+                <a:solidFill>
+                  <a:schemeClr val="tx1"/>
+                </a:solidFill>
+                <a:effectLst/>
+                <a:latin typeface="+mn-lt"/>
+                <a:ea typeface="+mn-ea"/>
+                <a:cs typeface="+mn-cs"/>
+              </a:rPr>
+              <a:t>velocità</a:t>
+            </a:r>
+            <a:r>
+              <a:rPr lang="en-GB" sz="1200" kern="1200" dirty="0">
+                <a:solidFill>
+                  <a:schemeClr val="tx1"/>
+                </a:solidFill>
+                <a:effectLst/>
+                <a:latin typeface="+mn-lt"/>
+                <a:ea typeface="+mn-ea"/>
+                <a:cs typeface="+mn-cs"/>
+              </a:rPr>
+              <a:t> non </a:t>
+            </a:r>
+            <a:r>
+              <a:rPr lang="en-GB" sz="1200" kern="1200" dirty="0" err="1">
+                <a:solidFill>
+                  <a:schemeClr val="tx1"/>
+                </a:solidFill>
+                <a:effectLst/>
+                <a:latin typeface="+mn-lt"/>
+                <a:ea typeface="+mn-ea"/>
+                <a:cs typeface="+mn-cs"/>
+              </a:rPr>
+              <a:t>è</a:t>
+            </a:r>
+            <a:r>
+              <a:rPr lang="en-GB" sz="1200" kern="1200" dirty="0">
+                <a:solidFill>
+                  <a:schemeClr val="tx1"/>
+                </a:solidFill>
+                <a:effectLst/>
+                <a:latin typeface="+mn-lt"/>
+                <a:ea typeface="+mn-ea"/>
+                <a:cs typeface="+mn-cs"/>
+              </a:rPr>
+              <a:t> </a:t>
+            </a:r>
+            <a:r>
+              <a:rPr lang="en-GB" sz="1200" kern="1200" dirty="0" err="1">
+                <a:solidFill>
+                  <a:schemeClr val="tx1"/>
+                </a:solidFill>
+                <a:effectLst/>
+                <a:latin typeface="+mn-lt"/>
+                <a:ea typeface="+mn-ea"/>
+                <a:cs typeface="+mn-cs"/>
+              </a:rPr>
+              <a:t>un'eccezione</a:t>
+            </a:r>
+            <a:r>
+              <a:rPr lang="en-GB" sz="1200" kern="1200" dirty="0">
+                <a:solidFill>
+                  <a:schemeClr val="tx1"/>
+                </a:solidFill>
+                <a:effectLst/>
+                <a:latin typeface="+mn-lt"/>
+                <a:ea typeface="+mn-ea"/>
+                <a:cs typeface="+mn-cs"/>
+              </a:rPr>
+              <a:t> </a:t>
+            </a:r>
+            <a:r>
+              <a:rPr lang="en-GB" sz="1200" kern="1200" dirty="0" err="1">
+                <a:solidFill>
+                  <a:schemeClr val="tx1"/>
+                </a:solidFill>
+                <a:effectLst/>
+                <a:latin typeface="+mn-lt"/>
+                <a:ea typeface="+mn-ea"/>
+                <a:cs typeface="+mn-cs"/>
+              </a:rPr>
+              <a:t>isolata</a:t>
+            </a:r>
+            <a:r>
+              <a:rPr lang="en-GB" sz="1200" kern="1200" dirty="0">
+                <a:solidFill>
+                  <a:schemeClr val="tx1"/>
+                </a:solidFill>
+                <a:effectLst/>
+                <a:latin typeface="+mn-lt"/>
+                <a:ea typeface="+mn-ea"/>
+                <a:cs typeface="+mn-cs"/>
+              </a:rPr>
+              <a:t>, ma il </a:t>
+            </a:r>
+            <a:r>
+              <a:rPr lang="en-GB" sz="1200" kern="1200" dirty="0" err="1">
+                <a:solidFill>
+                  <a:schemeClr val="tx1"/>
+                </a:solidFill>
+                <a:effectLst/>
+                <a:latin typeface="+mn-lt"/>
+                <a:ea typeface="+mn-ea"/>
+                <a:cs typeface="+mn-cs"/>
+              </a:rPr>
+              <a:t>comportamento</a:t>
+            </a:r>
+            <a:r>
+              <a:rPr lang="en-GB" sz="1200" kern="1200" dirty="0">
+                <a:solidFill>
+                  <a:schemeClr val="tx1"/>
+                </a:solidFill>
+                <a:effectLst/>
+                <a:latin typeface="+mn-lt"/>
+                <a:ea typeface="+mn-ea"/>
+                <a:cs typeface="+mn-cs"/>
+              </a:rPr>
+              <a:t> standard di </a:t>
+            </a:r>
+            <a:r>
+              <a:rPr lang="en-GB" sz="1200" kern="1200" dirty="0" err="1">
+                <a:solidFill>
+                  <a:schemeClr val="tx1"/>
+                </a:solidFill>
+                <a:effectLst/>
+                <a:latin typeface="+mn-lt"/>
+                <a:ea typeface="+mn-ea"/>
+                <a:cs typeface="+mn-cs"/>
+              </a:rPr>
+              <a:t>guida</a:t>
+            </a:r>
+            <a:r>
+              <a:rPr lang="en-GB" sz="1200" kern="1200" dirty="0">
+                <a:solidFill>
+                  <a:schemeClr val="tx1"/>
+                </a:solidFill>
+                <a:effectLst/>
+                <a:latin typeface="+mn-lt"/>
+                <a:ea typeface="+mn-ea"/>
+                <a:cs typeface="+mn-cs"/>
+              </a:rPr>
+              <a:t>. </a:t>
+            </a:r>
+            <a:endParaRPr lang="en-US" dirty="0"/>
+          </a:p>
+          <a:p>
+            <a:endParaRPr lang="en-US" dirty="0"/>
+          </a:p>
         </p:txBody>
       </p:sp>
       <p:sp>
@@ -1141,6 +2070,279 @@
             </a:r>
             <a:endParaRPr lang="en-US" dirty="0"/>
           </a:p>
+          <a:p>
+            <a:endParaRPr lang="en-US" dirty="0"/>
+          </a:p>
+          <a:p>
+            <a:r>
+              <a:rPr lang="en-US" dirty="0"/>
+              <a:t>Il </a:t>
+            </a:r>
+            <a:r>
+              <a:rPr lang="en-US" dirty="0" err="1"/>
+              <a:t>grafico</a:t>
+            </a:r>
+            <a:r>
+              <a:rPr lang="en-US" dirty="0"/>
+              <a:t> </a:t>
+            </a:r>
+            <a:r>
+              <a:rPr lang="en-US" dirty="0" err="1"/>
+              <a:t>mostra</a:t>
+            </a:r>
+            <a:r>
+              <a:rPr lang="en-US" dirty="0"/>
+              <a:t> il </a:t>
+            </a:r>
+            <a:r>
+              <a:rPr lang="en-US" dirty="0" err="1"/>
+              <a:t>tasso</a:t>
+            </a:r>
+            <a:r>
+              <a:rPr lang="en-US" dirty="0"/>
+              <a:t> di </a:t>
+            </a:r>
+            <a:r>
+              <a:rPr lang="en-US" dirty="0" err="1"/>
+              <a:t>infrazione</a:t>
+            </a:r>
+            <a:r>
+              <a:rPr lang="en-US" dirty="0"/>
+              <a:t> medio in </a:t>
+            </a:r>
+            <a:r>
+              <a:rPr lang="en-US" dirty="0" err="1"/>
+              <a:t>percentuale</a:t>
+            </a:r>
+            <a:r>
+              <a:rPr lang="en-US" dirty="0"/>
+              <a:t> per Giorno e ora, </a:t>
+            </a:r>
+            <a:r>
+              <a:rPr lang="en-US" dirty="0" err="1"/>
+              <a:t>noi</a:t>
+            </a:r>
+            <a:r>
+              <a:rPr lang="en-US" dirty="0"/>
+              <a:t> </a:t>
+            </a:r>
+            <a:r>
+              <a:rPr lang="en-US" dirty="0" err="1"/>
+              <a:t>abbiamo</a:t>
+            </a:r>
+            <a:r>
+              <a:rPr lang="en-US" dirty="0"/>
+              <a:t> la Colonna </a:t>
+            </a:r>
+            <a:r>
+              <a:rPr lang="en-US" dirty="0" err="1"/>
+              <a:t>tasso</a:t>
+            </a:r>
+            <a:r>
+              <a:rPr lang="en-US" dirty="0"/>
+              <a:t> </a:t>
+            </a:r>
+            <a:r>
+              <a:rPr lang="en-US" dirty="0" err="1"/>
+              <a:t>percentuale</a:t>
+            </a:r>
+            <a:r>
+              <a:rPr lang="en-US" dirty="0"/>
+              <a:t> di </a:t>
+            </a:r>
+            <a:r>
+              <a:rPr lang="en-US" dirty="0" err="1"/>
+              <a:t>infrazione</a:t>
+            </a:r>
+            <a:r>
+              <a:rPr lang="en-US" dirty="0"/>
+              <a:t> </a:t>
+            </a:r>
+            <a:r>
+              <a:rPr lang="en-US" dirty="0" err="1"/>
+              <a:t>abbiamo</a:t>
+            </a:r>
+            <a:r>
+              <a:rPr lang="en-US" dirty="0"/>
+              <a:t> </a:t>
+            </a:r>
+            <a:r>
+              <a:rPr lang="en-US" dirty="0" err="1"/>
+              <a:t>raggruppato</a:t>
+            </a:r>
+            <a:r>
+              <a:rPr lang="en-US" dirty="0"/>
+              <a:t> per Giorno e ora e ha </a:t>
+            </a:r>
+            <a:r>
+              <a:rPr lang="en-US" dirty="0" err="1"/>
+              <a:t>fatto</a:t>
+            </a:r>
+            <a:r>
+              <a:rPr lang="en-US" dirty="0"/>
+              <a:t> la media (</a:t>
+            </a:r>
+            <a:r>
+              <a:rPr lang="en-US" dirty="0" err="1"/>
+              <a:t>quindi</a:t>
+            </a:r>
+            <a:r>
+              <a:rPr lang="en-US" dirty="0"/>
+              <a:t> </a:t>
+            </a:r>
+            <a:r>
+              <a:rPr lang="en-US" dirty="0" err="1"/>
+              <a:t>lunedi</a:t>
+            </a:r>
+            <a:r>
+              <a:rPr lang="en-US" dirty="0"/>
+              <a:t> a 00 </a:t>
+            </a:r>
+            <a:r>
+              <a:rPr lang="en-US" dirty="0" err="1"/>
+              <a:t>rappresenta</a:t>
+            </a:r>
+            <a:r>
+              <a:rPr lang="en-US" dirty="0"/>
+              <a:t> la media del </a:t>
+            </a:r>
+            <a:r>
+              <a:rPr lang="en-US" dirty="0" err="1"/>
+              <a:t>tasso</a:t>
+            </a:r>
+            <a:r>
+              <a:rPr lang="en-US" dirty="0"/>
+              <a:t> di </a:t>
+            </a:r>
+            <a:r>
+              <a:rPr lang="en-US" dirty="0" err="1"/>
+              <a:t>infrazione</a:t>
+            </a:r>
+            <a:r>
+              <a:rPr lang="en-US" dirty="0"/>
+              <a:t> </a:t>
+            </a:r>
+            <a:r>
+              <a:rPr lang="en-US" dirty="0" err="1"/>
+              <a:t>percentuale</a:t>
+            </a:r>
+            <a:r>
+              <a:rPr lang="en-US" dirty="0"/>
+              <a:t> di tutti I </a:t>
+            </a:r>
+            <a:r>
+              <a:rPr lang="en-US" dirty="0" err="1"/>
+              <a:t>lunedi</a:t>
+            </a:r>
+            <a:r>
+              <a:rPr lang="en-US" dirty="0"/>
+              <a:t> alle 00)</a:t>
+            </a:r>
+          </a:p>
+          <a:p>
+            <a:endParaRPr lang="en-US" dirty="0"/>
+          </a:p>
+          <a:p>
+            <a:r>
+              <a:rPr lang="en-US" dirty="0" err="1"/>
+              <a:t>Cambiamenti</a:t>
+            </a:r>
+            <a:r>
+              <a:rPr lang="en-US" dirty="0"/>
+              <a:t>:</a:t>
+            </a:r>
+          </a:p>
+          <a:p>
+            <a:r>
+              <a:rPr lang="en-US" dirty="0"/>
+              <a:t>il </a:t>
+            </a:r>
+            <a:r>
+              <a:rPr lang="en-US" dirty="0" err="1"/>
+              <a:t>calcolo</a:t>
+            </a:r>
+            <a:r>
+              <a:rPr lang="en-US" dirty="0"/>
+              <a:t> del </a:t>
+            </a:r>
+            <a:r>
+              <a:rPr lang="en-US" dirty="0" err="1"/>
+              <a:t>tasso</a:t>
+            </a:r>
+            <a:r>
+              <a:rPr lang="en-US" dirty="0"/>
+              <a:t> in </a:t>
+            </a:r>
+            <a:r>
+              <a:rPr lang="en-US" dirty="0" err="1"/>
+              <a:t>percentuale</a:t>
+            </a:r>
+            <a:r>
+              <a:rPr lang="en-US" dirty="0"/>
+              <a:t> </a:t>
+            </a:r>
+            <a:r>
+              <a:rPr lang="en-US" dirty="0" err="1"/>
+              <a:t>puo</a:t>
+            </a:r>
+            <a:r>
+              <a:rPr lang="en-US" dirty="0"/>
+              <a:t> </a:t>
+            </a:r>
+            <a:r>
+              <a:rPr lang="en-US" dirty="0" err="1"/>
+              <a:t>essere</a:t>
+            </a:r>
+            <a:r>
+              <a:rPr lang="en-US" dirty="0"/>
+              <a:t> </a:t>
+            </a:r>
+            <a:r>
+              <a:rPr lang="en-US" dirty="0" err="1"/>
+              <a:t>fatto</a:t>
+            </a:r>
+            <a:r>
+              <a:rPr lang="en-US" dirty="0"/>
+              <a:t> in modo </a:t>
+            </a:r>
+            <a:r>
+              <a:rPr lang="en-US" dirty="0" err="1"/>
+              <a:t>manuale</a:t>
+            </a:r>
+            <a:r>
+              <a:rPr lang="en-US" dirty="0"/>
+              <a:t> o </a:t>
+            </a:r>
+            <a:r>
+              <a:rPr lang="en-US" dirty="0" err="1"/>
+              <a:t>calcolando</a:t>
+            </a:r>
+            <a:r>
+              <a:rPr lang="en-US" dirty="0"/>
+              <a:t> il </a:t>
+            </a:r>
+            <a:r>
+              <a:rPr lang="en-US" dirty="0" err="1"/>
+              <a:t>tasso</a:t>
+            </a:r>
+            <a:r>
+              <a:rPr lang="en-US" dirty="0"/>
+              <a:t> degli </a:t>
+            </a:r>
+            <a:r>
+              <a:rPr lang="en-US" dirty="0" err="1"/>
+              <a:t>ultimi</a:t>
+            </a:r>
+            <a:r>
+              <a:rPr lang="en-US" dirty="0"/>
+              <a:t> 7 </a:t>
+            </a:r>
+            <a:r>
+              <a:rPr lang="en-US" dirty="0" err="1"/>
+              <a:t>giorni</a:t>
+            </a:r>
+            <a:endParaRPr lang="en-US" dirty="0"/>
+          </a:p>
         </p:txBody>
       </p:sp>
       <p:sp>
@@ -1384,6 +2586,233 @@
               <a:t>.</a:t>
             </a:r>
           </a:p>
+          <a:p>
+            <a:endParaRPr lang="en-US" dirty="0"/>
+          </a:p>
+          <a:p>
+            <a:r>
+              <a:rPr lang="en-US" dirty="0" err="1"/>
+              <a:t>Creato</a:t>
+            </a:r>
+            <a:r>
+              <a:rPr lang="en-US" dirty="0"/>
+              <a:t> la Colonna </a:t>
+            </a:r>
+            <a:r>
+              <a:rPr lang="en-US" dirty="0" err="1"/>
+              <a:t>superamento</a:t>
+            </a:r>
+            <a:r>
+              <a:rPr lang="en-US" dirty="0"/>
+              <a:t> (</a:t>
+            </a:r>
+            <a:r>
+              <a:rPr lang="en-US" dirty="0" err="1"/>
+              <a:t>booleana</a:t>
+            </a:r>
+            <a:r>
+              <a:rPr lang="en-US" dirty="0"/>
+              <a:t>) se la </a:t>
+            </a:r>
+            <a:r>
+              <a:rPr lang="en-US" dirty="0" err="1"/>
+              <a:t>velocita</a:t>
+            </a:r>
+            <a:r>
+              <a:rPr lang="en-US" dirty="0"/>
+              <a:t> </a:t>
+            </a:r>
+            <a:r>
+              <a:rPr lang="en-US" dirty="0" err="1"/>
+              <a:t>è</a:t>
+            </a:r>
+            <a:r>
+              <a:rPr lang="en-US" dirty="0"/>
+              <a:t> Maggiore della zona </a:t>
+            </a:r>
+            <a:r>
+              <a:rPr lang="en-US" dirty="0" err="1"/>
+              <a:t>limite</a:t>
+            </a:r>
+            <a:r>
+              <a:rPr lang="en-US" dirty="0"/>
+              <a:t>, e poi </a:t>
+            </a:r>
+            <a:r>
+              <a:rPr lang="en-US" dirty="0" err="1"/>
+              <a:t>semplicemente</a:t>
+            </a:r>
+            <a:r>
+              <a:rPr lang="en-US" dirty="0"/>
+              <a:t> </a:t>
+            </a:r>
+            <a:r>
+              <a:rPr lang="en-US" dirty="0" err="1"/>
+              <a:t>raggruppiamo</a:t>
+            </a:r>
+            <a:r>
+              <a:rPr lang="en-US" dirty="0"/>
+              <a:t> per </a:t>
+            </a:r>
+            <a:r>
+              <a:rPr lang="en-US" dirty="0" err="1"/>
+              <a:t>lat</a:t>
+            </a:r>
+            <a:r>
+              <a:rPr lang="en-US" dirty="0"/>
+              <a:t> e </a:t>
+            </a:r>
+            <a:r>
+              <a:rPr lang="en-US" dirty="0" err="1"/>
+              <a:t>lon</a:t>
+            </a:r>
+            <a:r>
+              <a:rPr lang="en-US" dirty="0"/>
+              <a:t> (</a:t>
+            </a:r>
+            <a:r>
+              <a:rPr lang="en-US" dirty="0" err="1"/>
+              <a:t>quindi</a:t>
+            </a:r>
+            <a:r>
+              <a:rPr lang="en-US" dirty="0"/>
+              <a:t> per ogni radar) e </a:t>
+            </a:r>
+            <a:r>
+              <a:rPr lang="en-US" dirty="0" err="1"/>
+              <a:t>calcoliamo</a:t>
+            </a:r>
+            <a:r>
+              <a:rPr lang="en-US" dirty="0"/>
+              <a:t> per ogni radar il </a:t>
+            </a:r>
+            <a:r>
+              <a:rPr lang="en-US" dirty="0" err="1"/>
+              <a:t>numero</a:t>
+            </a:r>
+            <a:r>
+              <a:rPr lang="en-US" dirty="0"/>
+              <a:t> di </a:t>
+            </a:r>
+            <a:r>
+              <a:rPr lang="en-US" dirty="0" err="1"/>
+              <a:t>registrazioni</a:t>
+            </a:r>
+            <a:r>
+              <a:rPr lang="en-US" dirty="0"/>
+              <a:t> e il </a:t>
+            </a:r>
+            <a:r>
+              <a:rPr lang="en-US" dirty="0" err="1"/>
+              <a:t>numero</a:t>
+            </a:r>
+            <a:r>
+              <a:rPr lang="en-US" dirty="0"/>
+              <a:t> di </a:t>
+            </a:r>
+            <a:r>
+              <a:rPr lang="en-US" dirty="0" err="1"/>
+              <a:t>superamenti</a:t>
+            </a:r>
+            <a:endParaRPr lang="en-US" dirty="0"/>
+          </a:p>
+          <a:p>
+            <a:endParaRPr lang="en-US" dirty="0"/>
+          </a:p>
+          <a:p>
+            <a:r>
+              <a:rPr lang="en-US" dirty="0" err="1"/>
+              <a:t>Cambiamenti</a:t>
+            </a:r>
+            <a:r>
+              <a:rPr lang="en-US" dirty="0"/>
+              <a:t>:</a:t>
+            </a:r>
+          </a:p>
+          <a:p>
+            <a:r>
+              <a:rPr lang="en-US" dirty="0" err="1"/>
+              <a:t>implica</a:t>
+            </a:r>
+            <a:r>
+              <a:rPr lang="en-US" dirty="0"/>
+              <a:t> il </a:t>
+            </a:r>
+            <a:r>
+              <a:rPr lang="en-US" dirty="0" err="1"/>
+              <a:t>fatto</a:t>
+            </a:r>
+            <a:r>
+              <a:rPr lang="en-US" dirty="0"/>
+              <a:t> </a:t>
+            </a:r>
+            <a:r>
+              <a:rPr lang="en-US" dirty="0" err="1"/>
+              <a:t>che</a:t>
+            </a:r>
+            <a:r>
+              <a:rPr lang="en-US" dirty="0"/>
+              <a:t> </a:t>
+            </a:r>
+            <a:r>
+              <a:rPr lang="en-US" dirty="0" err="1"/>
+              <a:t>siano</a:t>
+            </a:r>
+            <a:r>
+              <a:rPr lang="en-US" dirty="0"/>
+              <a:t> </a:t>
+            </a:r>
+            <a:r>
+              <a:rPr lang="en-US" dirty="0" err="1"/>
+              <a:t>accesi</a:t>
+            </a:r>
+            <a:r>
+              <a:rPr lang="en-US" dirty="0"/>
+              <a:t> sempre (</a:t>
+            </a:r>
+            <a:r>
+              <a:rPr lang="en-US" dirty="0" err="1"/>
+              <a:t>verificare</a:t>
+            </a:r>
+            <a:r>
+              <a:rPr lang="en-US" dirty="0"/>
+              <a:t>)</a:t>
+            </a:r>
+          </a:p>
+          <a:p>
+            <a:r>
+              <a:rPr lang="en-US" dirty="0" err="1"/>
+              <a:t>cambiare</a:t>
+            </a:r>
+            <a:r>
+              <a:rPr lang="en-US" dirty="0"/>
+              <a:t> il </a:t>
+            </a:r>
+            <a:r>
+              <a:rPr lang="en-US" dirty="0" err="1"/>
+              <a:t>numero</a:t>
+            </a:r>
+            <a:r>
+              <a:rPr lang="en-US" dirty="0"/>
+              <a:t> di </a:t>
+            </a:r>
+            <a:r>
+              <a:rPr lang="en-US" dirty="0" err="1"/>
+              <a:t>infrazioni</a:t>
+            </a:r>
+            <a:r>
+              <a:rPr lang="en-US" dirty="0"/>
+              <a:t> con il TASSO DI INFRAZIONE in </a:t>
+            </a:r>
+            <a:r>
+              <a:rPr lang="en-US" dirty="0" err="1"/>
+              <a:t>percentuale</a:t>
+            </a:r>
+            <a:r>
+              <a:rPr lang="en-US" dirty="0"/>
+              <a:t>.</a:t>
+            </a:r>
+          </a:p>
         </p:txBody>
       </p:sp>
       <p:sp>
@@ -1636,6 +3065,240 @@
               <a:t>superamento</a:t>
             </a:r>
             <a:endParaRPr lang="en-US" dirty="0"/>
+          </a:p>
+          <a:p>
+            <a:endParaRPr lang="en-US" dirty="0"/>
+          </a:p>
+          <a:p>
+            <a:r>
+              <a:rPr lang="en-US" dirty="0" err="1"/>
+              <a:t>Cambiamenti</a:t>
+            </a:r>
+            <a:r>
+              <a:rPr lang="en-US" dirty="0"/>
+              <a:t>:</a:t>
+            </a:r>
+          </a:p>
+          <a:p>
+            <a:r>
+              <a:rPr lang="en-US" dirty="0"/>
+              <a:t>Nuovo </a:t>
+            </a:r>
+            <a:r>
+              <a:rPr lang="en-US" dirty="0" err="1"/>
+              <a:t>grafico</a:t>
+            </a:r>
+            <a:r>
+              <a:rPr lang="en-US" dirty="0"/>
+              <a:t> da fare heatmap:</a:t>
+            </a:r>
+          </a:p>
+          <a:p>
+            <a:r>
+              <a:rPr lang="en-US" dirty="0"/>
+              <a:t>asse x: tempo (anni dal 2024) e poi per ogni anno </a:t>
+            </a:r>
+            <a:r>
+              <a:rPr lang="en-US" dirty="0" err="1"/>
+              <a:t>mettiamo</a:t>
+            </a:r>
+            <a:r>
+              <a:rPr lang="en-US" dirty="0"/>
+              <a:t> </a:t>
+            </a:r>
+            <a:r>
+              <a:rPr lang="en-US" dirty="0" err="1"/>
+              <a:t>i</a:t>
+            </a:r>
+            <a:r>
+              <a:rPr lang="en-US" dirty="0"/>
+              <a:t> </a:t>
+            </a:r>
+            <a:r>
+              <a:rPr lang="en-US" dirty="0" err="1"/>
+              <a:t>mesi</a:t>
+            </a:r>
+            <a:endParaRPr lang="en-US" dirty="0"/>
+          </a:p>
+          <a:p>
+            <a:r>
+              <a:rPr lang="en-US" dirty="0"/>
+              <a:t>asse y: ogni radar</a:t>
+            </a:r>
+          </a:p>
+          <a:p>
+            <a:endParaRPr lang="en-US" dirty="0"/>
+          </a:p>
+          <a:p>
+            <a:r>
+              <a:rPr lang="en-US" dirty="0"/>
+              <a:t>la heatmap </a:t>
+            </a:r>
+            <a:r>
+              <a:rPr lang="en-US" dirty="0" err="1"/>
+              <a:t>deve</a:t>
+            </a:r>
+            <a:r>
+              <a:rPr lang="en-US" dirty="0"/>
+              <a:t> </a:t>
+            </a:r>
+            <a:r>
+              <a:rPr lang="en-US" dirty="0" err="1"/>
+              <a:t>rappresentare</a:t>
+            </a:r>
+            <a:r>
+              <a:rPr lang="en-US" dirty="0"/>
+              <a:t> il </a:t>
+            </a:r>
+            <a:r>
+              <a:rPr lang="en-US" dirty="0" err="1"/>
+              <a:t>numero</a:t>
+            </a:r>
+            <a:r>
+              <a:rPr lang="en-US" dirty="0"/>
+              <a:t> di </a:t>
+            </a:r>
+            <a:r>
+              <a:rPr lang="en-US" dirty="0" err="1"/>
+              <a:t>automobili</a:t>
+            </a:r>
+            <a:r>
+              <a:rPr lang="en-US" dirty="0"/>
+              <a:t> (o se ne </a:t>
+            </a:r>
+            <a:r>
+              <a:rPr lang="en-US" dirty="0" err="1"/>
+              <a:t>è</a:t>
+            </a:r>
+            <a:r>
+              <a:rPr lang="en-US" dirty="0"/>
+              <a:t> passata </a:t>
+            </a:r>
+            <a:r>
+              <a:rPr lang="en-US" dirty="0" err="1"/>
+              <a:t>almeno</a:t>
+            </a:r>
+            <a:r>
+              <a:rPr lang="en-US" dirty="0"/>
+              <a:t> </a:t>
+            </a:r>
+            <a:r>
+              <a:rPr lang="en-US" dirty="0" err="1"/>
+              <a:t>una</a:t>
+            </a:r>
+            <a:r>
+              <a:rPr lang="en-US" dirty="0"/>
+              <a:t> e </a:t>
+            </a:r>
+            <a:r>
+              <a:rPr lang="en-US" dirty="0" err="1"/>
+              <a:t>quindi</a:t>
+            </a:r>
+            <a:r>
+              <a:rPr lang="en-US" dirty="0"/>
+              <a:t> </a:t>
+            </a:r>
+            <a:r>
+              <a:rPr lang="en-US" dirty="0" err="1"/>
+              <a:t>avro</a:t>
+            </a:r>
+            <a:r>
+              <a:rPr lang="en-US" dirty="0"/>
+              <a:t> </a:t>
+            </a:r>
+            <a:r>
+              <a:rPr lang="en-US" dirty="0" err="1"/>
+              <a:t>i</a:t>
+            </a:r>
+            <a:r>
+              <a:rPr lang="en-US" dirty="0"/>
+              <a:t> </a:t>
+            </a:r>
+            <a:r>
+              <a:rPr lang="en-US" dirty="0" err="1"/>
+              <a:t>quadrati</a:t>
+            </a:r>
+            <a:r>
+              <a:rPr lang="en-US" dirty="0"/>
+              <a:t> o </a:t>
+            </a:r>
+            <a:r>
+              <a:rPr lang="en-US" dirty="0" err="1"/>
+              <a:t>bianchi</a:t>
+            </a:r>
+            <a:r>
+              <a:rPr lang="en-US" dirty="0"/>
+              <a:t> o </a:t>
+            </a:r>
+            <a:r>
+              <a:rPr lang="en-US" dirty="0" err="1"/>
+              <a:t>neri</a:t>
+            </a:r>
+            <a:r>
+              <a:rPr lang="en-US" dirty="0"/>
+              <a:t> per </a:t>
+            </a:r>
+            <a:r>
+              <a:rPr lang="en-US" dirty="0" err="1"/>
+              <a:t>verificare</a:t>
+            </a:r>
+            <a:r>
+              <a:rPr lang="en-US" dirty="0"/>
+              <a:t> </a:t>
+            </a:r>
+            <a:r>
+              <a:rPr lang="en-US" dirty="0" err="1"/>
+              <a:t>che</a:t>
+            </a:r>
+            <a:r>
+              <a:rPr lang="en-US" dirty="0"/>
+              <a:t> </a:t>
+            </a:r>
+            <a:r>
+              <a:rPr lang="en-US" dirty="0" err="1"/>
+              <a:t>sono</a:t>
+            </a:r>
+            <a:r>
+              <a:rPr lang="en-US" dirty="0"/>
+              <a:t> sempre </a:t>
+            </a:r>
+            <a:r>
+              <a:rPr lang="en-US" dirty="0" err="1"/>
+              <a:t>accesi</a:t>
+            </a:r>
+            <a:r>
+              <a:rPr lang="en-US" dirty="0"/>
+              <a:t> I radar)</a:t>
+            </a:r>
+          </a:p>
+          <a:p>
+            <a:endParaRPr lang="en-US" dirty="0"/>
+          </a:p>
+          <a:p>
+            <a:r>
+              <a:rPr lang="en-US" dirty="0" err="1"/>
+              <a:t>raggruppamento</a:t>
+            </a:r>
+            <a:r>
+              <a:rPr lang="en-US" dirty="0"/>
+              <a:t> </a:t>
+            </a:r>
+            <a:r>
+              <a:rPr lang="en-US" dirty="0" err="1"/>
+              <a:t>si</a:t>
+            </a:r>
+            <a:r>
+              <a:rPr lang="en-US" dirty="0"/>
+              <a:t> </a:t>
+            </a:r>
+            <a:r>
+              <a:rPr lang="en-US" dirty="0" err="1"/>
+              <a:t>chiama</a:t>
+            </a:r>
+            <a:r>
+              <a:rPr lang="en-US" dirty="0"/>
+              <a:t> resampling</a:t>
+            </a:r>
           </a:p>
           <a:p>
             <a:endParaRPr lang="en-US" dirty="0"/>
@@ -2400,7 +4063,7 @@
                 <a:ea typeface="Calibri" pitchFamily="34" charset="-122"/>
                 <a:cs typeface="Calibri" pitchFamily="34" charset="-120"/>
               </a:rPr>
-              <a:t>Data Science</a:t>
+              <a:t>Data Science – Group A</a:t>
             </a:r>
             <a:endParaRPr lang="en-US" sz="1600" dirty="0"/>
           </a:p>

</xml_diff>

<commit_message>
Modifica grafici di andre
</commit_message>
<xml_diff>
--- a/speed_monitoring.pptx
+++ b/speed_monitoring.pptx
@@ -645,99 +645,6 @@
           <a:lstStyle/>
           <a:p>
             <a:r>
-              <a:rPr lang="en-US" dirty="0"/>
-              <a:t>zoom </a:t>
-            </a:r>
-            <a:r>
-              <a:rPr lang="en-US" dirty="0" err="1"/>
-              <a:t>sul</a:t>
-            </a:r>
-            <a:r>
-              <a:rPr lang="en-US" dirty="0"/>
-              <a:t> primo e </a:t>
-            </a:r>
-            <a:r>
-              <a:rPr lang="en-US" dirty="0" err="1"/>
-              <a:t>mostraer</a:t>
-            </a:r>
-            <a:r>
-              <a:rPr lang="en-US" dirty="0"/>
-              <a:t> </a:t>
-            </a:r>
-            <a:r>
-              <a:rPr lang="en-US" dirty="0" err="1"/>
-              <a:t>una</a:t>
-            </a:r>
-            <a:r>
-              <a:rPr lang="en-US" dirty="0"/>
-              <a:t> </a:t>
-            </a:r>
-            <a:r>
-              <a:rPr lang="en-US" dirty="0" err="1"/>
-              <a:t>distribuziobe</a:t>
-            </a:r>
-            <a:r>
-              <a:rPr lang="en-US" dirty="0"/>
-              <a:t> delle </a:t>
-            </a:r>
-            <a:r>
-              <a:rPr lang="en-US" dirty="0" err="1"/>
-              <a:t>velocit`MISURATE</a:t>
-            </a:r>
-            <a:endParaRPr lang="en-US" dirty="0"/>
-          </a:p>
-          <a:p>
-            <a:r>
-              <a:rPr lang="en-US" dirty="0" err="1"/>
-              <a:t>mostra</a:t>
-            </a:r>
-            <a:r>
-              <a:rPr lang="en-US" dirty="0"/>
-              <a:t> campana </a:t>
-            </a:r>
-            <a:r>
-              <a:rPr lang="en-US" dirty="0" err="1"/>
-              <a:t>velocita</a:t>
-            </a:r>
-            <a:r>
-              <a:rPr lang="en-US" dirty="0"/>
-              <a:t> con </a:t>
-            </a:r>
-            <a:r>
-              <a:rPr lang="en-US" dirty="0" err="1"/>
-              <a:t>rigfa</a:t>
-            </a:r>
-            <a:r>
-              <a:rPr lang="en-US" dirty="0"/>
-              <a:t> </a:t>
-            </a:r>
-            <a:r>
-              <a:rPr lang="en-US" dirty="0" err="1"/>
-              <a:t>verticale</a:t>
-            </a:r>
-            <a:r>
-              <a:rPr lang="en-US" dirty="0"/>
-              <a:t> con dove </a:t>
-            </a:r>
-            <a:r>
-              <a:rPr lang="en-US" dirty="0" err="1"/>
-              <a:t>inizia</a:t>
-            </a:r>
-            <a:r>
-              <a:rPr lang="en-US" dirty="0"/>
-              <a:t> la </a:t>
-            </a:r>
-            <a:r>
-              <a:rPr lang="en-US" dirty="0" err="1"/>
-              <a:t>infrazione</a:t>
-            </a:r>
-            <a:endParaRPr lang="en-US" dirty="0"/>
-          </a:p>
-          <a:p>
-            <a:endParaRPr lang="en-US" dirty="0"/>
-          </a:p>
-          <a:p>
-            <a:r>
               <a:rPr lang="en-GB" sz="1200" kern="1200" dirty="0">
                 <a:solidFill>
                   <a:schemeClr val="tx1"/>
@@ -1755,7 +1662,7 @@
           <a:p>
             <a:r>
               <a:rPr lang="en-US" dirty="0" err="1"/>
-              <a:t>strano</a:t>
+              <a:t>Sembra</a:t>
             </a:r>
             <a:r>
               <a:rPr lang="en-US" dirty="0"/>
@@ -1763,7 +1670,7 @@
             </a:r>
             <a:r>
               <a:rPr lang="en-US" dirty="0" err="1"/>
-              <a:t>che</a:t>
+              <a:t>strano</a:t>
             </a:r>
             <a:r>
               <a:rPr lang="en-US" dirty="0"/>
@@ -1771,7 +1678,7 @@
             </a:r>
             <a:r>
               <a:rPr lang="en-US" dirty="0" err="1"/>
-              <a:t>c'è</a:t>
+              <a:t>che</a:t>
             </a:r>
             <a:r>
               <a:rPr lang="en-US" dirty="0"/>
@@ -1779,7 +1686,7 @@
             </a:r>
             <a:r>
               <a:rPr lang="en-US" dirty="0" err="1"/>
-              <a:t>più</a:t>
+              <a:t>c'è</a:t>
             </a:r>
             <a:r>
               <a:rPr lang="en-US" dirty="0"/>
@@ -1787,33 +1694,25 @@
             </a:r>
             <a:r>
               <a:rPr lang="en-US" dirty="0" err="1"/>
+              <a:t>più</a:t>
+            </a:r>
+            <a:r>
+              <a:rPr lang="en-US" dirty="0"/>
+              <a:t> </a:t>
+            </a:r>
+            <a:r>
+              <a:rPr lang="en-US" dirty="0" err="1"/>
               <a:t>traffico</a:t>
             </a:r>
             <a:r>
               <a:rPr lang="en-US" dirty="0"/>
               <a:t> alle 15 rispetto alle 17</a:t>
             </a:r>
-            <a:br>
-              <a:rPr lang="en-US" dirty="0"/>
-            </a:br>
-            <a:br>
-              <a:rPr lang="en-US" dirty="0"/>
-            </a:br>
-            <a:r>
-              <a:rPr lang="en-US" dirty="0"/>
-              <a:t>Di notte non </a:t>
-            </a:r>
+          </a:p>
+          <a:p>
             <a:r>
               <a:rPr lang="en-US" dirty="0" err="1"/>
-              <a:t>c'è</a:t>
-            </a:r>
-            <a:r>
-              <a:rPr lang="en-US" dirty="0"/>
-              <a:t> il radar </a:t>
-            </a:r>
-            <a:r>
-              <a:rPr lang="en-US" dirty="0" err="1"/>
-              <a:t>nella</a:t>
+              <a:t>Semplicemente</a:t>
             </a:r>
             <a:r>
               <a:rPr lang="en-US" dirty="0"/>
@@ -1821,23 +1720,15 @@
             </a:r>
             <a:r>
               <a:rPr lang="en-US" dirty="0" err="1"/>
-              <a:t>stradina</a:t>
+              <a:t>perché</a:t>
             </a:r>
             <a:r>
               <a:rPr lang="en-US" dirty="0"/>
-              <a:t> di </a:t>
+              <a:t> ci </a:t>
             </a:r>
             <a:r>
               <a:rPr lang="en-US" dirty="0" err="1"/>
-              <a:t>paese</a:t>
-            </a:r>
-            <a:r>
-              <a:rPr lang="en-US" dirty="0"/>
-              <a:t> ma </a:t>
-            </a:r>
-            <a:r>
-              <a:rPr lang="en-US" dirty="0" err="1"/>
-              <a:t>nelle</a:t>
+              <a:t>sono</a:t>
             </a:r>
             <a:r>
               <a:rPr lang="en-US" dirty="0"/>
@@ -1845,7 +1736,7 @@
             </a:r>
             <a:r>
               <a:rPr lang="en-US" dirty="0" err="1"/>
-              <a:t>strade</a:t>
+              <a:t>più</a:t>
             </a:r>
             <a:r>
               <a:rPr lang="en-US" dirty="0"/>
@@ -1853,22 +1744,15 @@
             </a:r>
             <a:r>
               <a:rPr lang="en-US" dirty="0" err="1"/>
-              <a:t>veloci</a:t>
+              <a:t>controlli</a:t>
             </a:r>
             <a:r>
               <a:rPr lang="en-US" dirty="0"/>
-              <a:t>?</a:t>
-            </a:r>
-            <a:br>
-              <a:rPr lang="en-US" dirty="0"/>
-            </a:br>
-            <a:r>
-              <a:rPr lang="en-US" dirty="0"/>
-              <a:t>Vedi se </a:t>
+              <a:t> in </a:t>
             </a:r>
             <a:r>
               <a:rPr lang="en-US" dirty="0" err="1"/>
-              <a:t>è</a:t>
+              <a:t>strade</a:t>
             </a:r>
             <a:r>
               <a:rPr lang="en-US" dirty="0"/>
@@ -1876,9 +1760,28 @@
             </a:r>
             <a:r>
               <a:rPr lang="en-US" dirty="0" err="1"/>
-              <a:t>vero</a:t>
-            </a:r>
-            <a:endParaRPr lang="en-US" dirty="0"/>
+              <a:t>cantonali</a:t>
+            </a:r>
+            <a:r>
+              <a:rPr lang="en-US" dirty="0"/>
+              <a:t> </a:t>
+            </a:r>
+            <a:r>
+              <a:rPr lang="en-US" dirty="0" err="1"/>
+              <a:t>ecc</a:t>
+            </a:r>
+            <a:r>
+              <a:rPr lang="en-US" dirty="0"/>
+              <a:t>. e non solo in </a:t>
+            </a:r>
+            <a:r>
+              <a:rPr lang="en-US" dirty="0" err="1"/>
+              <a:t>stradine</a:t>
+            </a:r>
+            <a:r>
+              <a:rPr lang="en-US" dirty="0"/>
+              <a:t> lente (30kmh)</a:t>
+            </a:r>
           </a:p>
         </p:txBody>
       </p:sp>
@@ -1980,367 +1883,6 @@
           <a:bodyPr/>
           <a:lstStyle/>
           <a:p>
-            <a:r>
-              <a:rPr lang="en-US" dirty="0"/>
-              <a:t>Si nota </a:t>
-            </a:r>
-            <a:r>
-              <a:rPr lang="en-US" dirty="0" err="1"/>
-              <a:t>che</a:t>
-            </a:r>
-            <a:r>
-              <a:rPr lang="en-US" dirty="0"/>
-              <a:t> le </a:t>
-            </a:r>
-            <a:r>
-              <a:rPr lang="en-US" dirty="0" err="1"/>
-              <a:t>infrazioni</a:t>
-            </a:r>
-            <a:r>
-              <a:rPr lang="en-US" dirty="0"/>
-              <a:t> </a:t>
-            </a:r>
-            <a:r>
-              <a:rPr lang="en-US" dirty="0" err="1"/>
-              <a:t>avvengono</a:t>
-            </a:r>
-            <a:r>
-              <a:rPr lang="en-US" dirty="0"/>
-              <a:t> </a:t>
-            </a:r>
-            <a:r>
-              <a:rPr lang="en-US" dirty="0" err="1"/>
-              <a:t>maggiormente</a:t>
-            </a:r>
-            <a:r>
-              <a:rPr lang="en-US" dirty="0"/>
-              <a:t> </a:t>
-            </a:r>
-            <a:r>
-              <a:rPr lang="en-US" dirty="0" err="1"/>
-              <a:t>negli</a:t>
-            </a:r>
-            <a:r>
-              <a:rPr lang="en-US" dirty="0"/>
-              <a:t> </a:t>
-            </a:r>
-            <a:r>
-              <a:rPr lang="en-US" dirty="0" err="1"/>
-              <a:t>orari</a:t>
-            </a:r>
-            <a:r>
-              <a:rPr lang="en-US" dirty="0"/>
-              <a:t> con </a:t>
-            </a:r>
-            <a:r>
-              <a:rPr lang="en-US" dirty="0" err="1"/>
-              <a:t>pochissimo</a:t>
-            </a:r>
-            <a:r>
-              <a:rPr lang="en-US" dirty="0"/>
-              <a:t> </a:t>
-            </a:r>
-            <a:r>
-              <a:rPr lang="en-US" dirty="0" err="1"/>
-              <a:t>traffico</a:t>
-            </a:r>
-            <a:r>
-              <a:rPr lang="en-US" dirty="0"/>
-              <a:t> -&gt; dove ci </a:t>
-            </a:r>
-            <a:r>
-              <a:rPr lang="en-US" dirty="0" err="1"/>
-              <a:t>sono</a:t>
-            </a:r>
-            <a:r>
-              <a:rPr lang="en-US" dirty="0"/>
-              <a:t> </a:t>
-            </a:r>
-            <a:r>
-              <a:rPr lang="en-US" dirty="0" err="1"/>
-              <a:t>meno</a:t>
-            </a:r>
-            <a:r>
-              <a:rPr lang="en-US" dirty="0"/>
-              <a:t> </a:t>
-            </a:r>
-            <a:r>
-              <a:rPr lang="en-US" dirty="0" err="1"/>
-              <a:t>misurazioni</a:t>
-            </a:r>
-            <a:endParaRPr lang="en-US" dirty="0"/>
-          </a:p>
-          <a:p>
-            <a:endParaRPr lang="en-US" dirty="0"/>
-          </a:p>
-          <a:p>
-            <a:r>
-              <a:rPr lang="en-US" dirty="0"/>
-              <a:t>Il </a:t>
-            </a:r>
-            <a:r>
-              <a:rPr lang="en-US" dirty="0" err="1"/>
-              <a:t>grafico</a:t>
-            </a:r>
-            <a:r>
-              <a:rPr lang="en-US" dirty="0"/>
-              <a:t> </a:t>
-            </a:r>
-            <a:r>
-              <a:rPr lang="en-US" dirty="0" err="1"/>
-              <a:t>mostra</a:t>
-            </a:r>
-            <a:r>
-              <a:rPr lang="en-US" dirty="0"/>
-              <a:t> il </a:t>
-            </a:r>
-            <a:r>
-              <a:rPr lang="en-US" dirty="0" err="1"/>
-              <a:t>tasso</a:t>
-            </a:r>
-            <a:r>
-              <a:rPr lang="en-US" dirty="0"/>
-              <a:t> di </a:t>
-            </a:r>
-            <a:r>
-              <a:rPr lang="en-US" dirty="0" err="1"/>
-              <a:t>infrazione</a:t>
-            </a:r>
-            <a:r>
-              <a:rPr lang="en-US" dirty="0"/>
-              <a:t> medio in </a:t>
-            </a:r>
-            <a:r>
-              <a:rPr lang="en-US" dirty="0" err="1"/>
-              <a:t>percentuale</a:t>
-            </a:r>
-            <a:r>
-              <a:rPr lang="en-US" dirty="0"/>
-              <a:t> per Giorno e ora, </a:t>
-            </a:r>
-            <a:r>
-              <a:rPr lang="en-US" dirty="0" err="1"/>
-              <a:t>noi</a:t>
-            </a:r>
-            <a:r>
-              <a:rPr lang="en-US" dirty="0"/>
-              <a:t> </a:t>
-            </a:r>
-            <a:r>
-              <a:rPr lang="en-US" dirty="0" err="1"/>
-              <a:t>abbiamo</a:t>
-            </a:r>
-            <a:r>
-              <a:rPr lang="en-US" dirty="0"/>
-              <a:t> la Colonna </a:t>
-            </a:r>
-            <a:r>
-              <a:rPr lang="en-US" dirty="0" err="1"/>
-              <a:t>tasso</a:t>
-            </a:r>
-            <a:r>
-              <a:rPr lang="en-US" dirty="0"/>
-              <a:t> </a:t>
-            </a:r>
-            <a:r>
-              <a:rPr lang="en-US" dirty="0" err="1"/>
-              <a:t>percentuale</a:t>
-            </a:r>
-            <a:r>
-              <a:rPr lang="en-US" dirty="0"/>
-              <a:t> di </a:t>
-            </a:r>
-            <a:r>
-              <a:rPr lang="en-US" dirty="0" err="1"/>
-              <a:t>infrazione</a:t>
-            </a:r>
-            <a:r>
-              <a:rPr lang="en-US" dirty="0"/>
-              <a:t> </a:t>
-            </a:r>
-            <a:r>
-              <a:rPr lang="en-US" dirty="0" err="1"/>
-              <a:t>abbiamo</a:t>
-            </a:r>
-            <a:r>
-              <a:rPr lang="en-US" dirty="0"/>
-              <a:t> </a:t>
-            </a:r>
-            <a:r>
-              <a:rPr lang="en-US" dirty="0" err="1"/>
-              <a:t>raggruppato</a:t>
-            </a:r>
-            <a:r>
-              <a:rPr lang="en-US" dirty="0"/>
-              <a:t> per Giorno e ora e ha </a:t>
-            </a:r>
-            <a:r>
-              <a:rPr lang="en-US" dirty="0" err="1"/>
-              <a:t>fatto</a:t>
-            </a:r>
-            <a:r>
-              <a:rPr lang="en-US" dirty="0"/>
-              <a:t> la media (</a:t>
-            </a:r>
-            <a:r>
-              <a:rPr lang="en-US" dirty="0" err="1"/>
-              <a:t>quindi</a:t>
-            </a:r>
-            <a:r>
-              <a:rPr lang="en-US" dirty="0"/>
-              <a:t> </a:t>
-            </a:r>
-            <a:r>
-              <a:rPr lang="en-US" dirty="0" err="1"/>
-              <a:t>lunedi</a:t>
-            </a:r>
-            <a:r>
-              <a:rPr lang="en-US" dirty="0"/>
-              <a:t> a 00 </a:t>
-            </a:r>
-            <a:r>
-              <a:rPr lang="en-US" dirty="0" err="1"/>
-              <a:t>rappresenta</a:t>
-            </a:r>
-            <a:r>
-              <a:rPr lang="en-US" dirty="0"/>
-              <a:t> la media del </a:t>
-            </a:r>
-            <a:r>
-              <a:rPr lang="en-US" dirty="0" err="1"/>
-              <a:t>tasso</a:t>
-            </a:r>
-            <a:r>
-              <a:rPr lang="en-US" dirty="0"/>
-              <a:t> di </a:t>
-            </a:r>
-            <a:r>
-              <a:rPr lang="en-US" dirty="0" err="1"/>
-              <a:t>infrazione</a:t>
-            </a:r>
-            <a:r>
-              <a:rPr lang="en-US" dirty="0"/>
-              <a:t> </a:t>
-            </a:r>
-            <a:r>
-              <a:rPr lang="en-US" dirty="0" err="1"/>
-              <a:t>percentuale</a:t>
-            </a:r>
-            <a:r>
-              <a:rPr lang="en-US" dirty="0"/>
-              <a:t> di tutti I </a:t>
-            </a:r>
-            <a:r>
-              <a:rPr lang="en-US" dirty="0" err="1"/>
-              <a:t>lunedi</a:t>
-            </a:r>
-            <a:r>
-              <a:rPr lang="en-US" dirty="0"/>
-              <a:t> alle 00)</a:t>
-            </a:r>
-          </a:p>
-          <a:p>
-            <a:endParaRPr lang="en-US" dirty="0"/>
-          </a:p>
-          <a:p>
-            <a:r>
-              <a:rPr lang="en-US" dirty="0" err="1"/>
-              <a:t>Cambiamenti</a:t>
-            </a:r>
-            <a:r>
-              <a:rPr lang="en-US" dirty="0"/>
-              <a:t>:</a:t>
-            </a:r>
-          </a:p>
-          <a:p>
-            <a:r>
-              <a:rPr lang="en-US" dirty="0"/>
-              <a:t>il </a:t>
-            </a:r>
-            <a:r>
-              <a:rPr lang="en-US" dirty="0" err="1"/>
-              <a:t>calcolo</a:t>
-            </a:r>
-            <a:r>
-              <a:rPr lang="en-US" dirty="0"/>
-              <a:t> del </a:t>
-            </a:r>
-            <a:r>
-              <a:rPr lang="en-US" dirty="0" err="1"/>
-              <a:t>tasso</a:t>
-            </a:r>
-            <a:r>
-              <a:rPr lang="en-US" dirty="0"/>
-              <a:t> in </a:t>
-            </a:r>
-            <a:r>
-              <a:rPr lang="en-US" dirty="0" err="1"/>
-              <a:t>percentuale</a:t>
-            </a:r>
-            <a:r>
-              <a:rPr lang="en-US" dirty="0"/>
-              <a:t> </a:t>
-            </a:r>
-            <a:r>
-              <a:rPr lang="en-US" dirty="0" err="1"/>
-              <a:t>puo</a:t>
-            </a:r>
-            <a:r>
-              <a:rPr lang="en-US" dirty="0"/>
-              <a:t> </a:t>
-            </a:r>
-            <a:r>
-              <a:rPr lang="en-US" dirty="0" err="1"/>
-              <a:t>essere</a:t>
-            </a:r>
-            <a:r>
-              <a:rPr lang="en-US" dirty="0"/>
-              <a:t> </a:t>
-            </a:r>
-            <a:r>
-              <a:rPr lang="en-US" dirty="0" err="1"/>
-              <a:t>fatto</a:t>
-            </a:r>
-            <a:r>
-              <a:rPr lang="en-US" dirty="0"/>
-              <a:t> in modo </a:t>
-            </a:r>
-            <a:r>
-              <a:rPr lang="en-US" dirty="0" err="1"/>
-              <a:t>manuale</a:t>
-            </a:r>
-            <a:r>
-              <a:rPr lang="en-US" dirty="0"/>
-              <a:t> o </a:t>
-            </a:r>
-            <a:r>
-              <a:rPr lang="en-US" dirty="0" err="1"/>
-              <a:t>calcolando</a:t>
-            </a:r>
-            <a:r>
-              <a:rPr lang="en-US" dirty="0"/>
-              <a:t> il </a:t>
-            </a:r>
-            <a:r>
-              <a:rPr lang="en-US" dirty="0" err="1"/>
-              <a:t>tasso</a:t>
-            </a:r>
-            <a:r>
-              <a:rPr lang="en-US" dirty="0"/>
-              <a:t> degli </a:t>
-            </a:r>
-            <a:r>
-              <a:rPr lang="en-US" dirty="0" err="1"/>
-              <a:t>ultimi</a:t>
-            </a:r>
-            <a:r>
-              <a:rPr lang="en-US" dirty="0"/>
-              <a:t> 7 </a:t>
-            </a:r>
-            <a:r>
-              <a:rPr lang="en-US" dirty="0" err="1"/>
-              <a:t>giorni</a:t>
-            </a:r>
             <a:endParaRPr lang="en-US" dirty="0"/>
           </a:p>
         </p:txBody>
@@ -2450,367 +1992,58 @@
           <a:lstStyle/>
           <a:p>
             <a:r>
-              <a:rPr lang="en-US" dirty="0" err="1"/>
-              <a:t>Mostra</a:t>
-            </a:r>
-            <a:r>
-              <a:rPr lang="en-US" dirty="0"/>
-              <a:t> la </a:t>
-            </a:r>
-            <a:r>
-              <a:rPr lang="en-US" dirty="0" err="1"/>
-              <a:t>correlazione</a:t>
-            </a:r>
-            <a:r>
-              <a:rPr lang="en-US" dirty="0"/>
-              <a:t> </a:t>
-            </a:r>
-            <a:r>
-              <a:rPr lang="en-US" dirty="0" err="1"/>
-              <a:t>tra</a:t>
-            </a:r>
-            <a:r>
-              <a:rPr lang="en-US" dirty="0"/>
-              <a:t> volume di </a:t>
-            </a:r>
-            <a:r>
-              <a:rPr lang="en-US" dirty="0" err="1"/>
-              <a:t>traffico</a:t>
-            </a:r>
-            <a:r>
-              <a:rPr lang="en-US" dirty="0"/>
-              <a:t> (grandezza </a:t>
-            </a:r>
-            <a:r>
-              <a:rPr lang="en-US" dirty="0" err="1"/>
-              <a:t>pallino</a:t>
-            </a:r>
-            <a:r>
-              <a:rPr lang="en-US" dirty="0"/>
-              <a:t>), e </a:t>
-            </a:r>
-            <a:r>
-              <a:rPr lang="en-US" dirty="0" err="1"/>
-              <a:t>numero</a:t>
-            </a:r>
-            <a:r>
-              <a:rPr lang="en-US" dirty="0"/>
-              <a:t> di </a:t>
-            </a:r>
-            <a:r>
-              <a:rPr lang="en-US" dirty="0" err="1"/>
-              <a:t>infrazioni</a:t>
-            </a:r>
-            <a:r>
-              <a:rPr lang="en-US" dirty="0"/>
-              <a:t> (</a:t>
-            </a:r>
-            <a:r>
-              <a:rPr lang="en-US" dirty="0" err="1"/>
-              <a:t>colore</a:t>
-            </a:r>
-            <a:r>
-              <a:rPr lang="en-US" dirty="0"/>
-              <a:t>); Ci </a:t>
-            </a:r>
-            <a:r>
-              <a:rPr lang="en-US" dirty="0" err="1"/>
-              <a:t>siamo</a:t>
-            </a:r>
-            <a:r>
-              <a:rPr lang="en-US" dirty="0"/>
-              <a:t> </a:t>
-            </a:r>
-            <a:r>
-              <a:rPr lang="en-US" dirty="0" err="1"/>
-              <a:t>chiesti</a:t>
-            </a:r>
-            <a:r>
-              <a:rPr lang="en-US" dirty="0"/>
-              <a:t> se le </a:t>
-            </a:r>
-            <a:r>
-              <a:rPr lang="en-US" dirty="0" err="1"/>
-              <a:t>strade</a:t>
-            </a:r>
-            <a:r>
-              <a:rPr lang="en-US" dirty="0"/>
-              <a:t> piu </a:t>
-            </a:r>
-            <a:r>
-              <a:rPr lang="en-US" dirty="0" err="1"/>
-              <a:t>trafficate</a:t>
-            </a:r>
-            <a:r>
-              <a:rPr lang="en-US" dirty="0"/>
-              <a:t> </a:t>
-            </a:r>
-            <a:r>
-              <a:rPr lang="en-US" dirty="0" err="1"/>
-              <a:t>fossero</a:t>
-            </a:r>
-            <a:r>
-              <a:rPr lang="en-US" dirty="0"/>
-              <a:t> </a:t>
-            </a:r>
-            <a:r>
-              <a:rPr lang="en-US" dirty="0" err="1"/>
-              <a:t>anche</a:t>
-            </a:r>
-            <a:r>
-              <a:rPr lang="en-US" dirty="0"/>
-              <a:t> quelle dove </a:t>
-            </a:r>
-            <a:r>
-              <a:rPr lang="en-US" dirty="0" err="1"/>
-              <a:t>vengono</a:t>
-            </a:r>
-            <a:r>
-              <a:rPr lang="en-US" dirty="0"/>
-              <a:t> </a:t>
-            </a:r>
-            <a:r>
-              <a:rPr lang="en-US" dirty="0" err="1"/>
-              <a:t>effettuate</a:t>
-            </a:r>
-            <a:r>
-              <a:rPr lang="en-US" dirty="0"/>
-              <a:t> piu </a:t>
-            </a:r>
-            <a:r>
-              <a:rPr lang="en-US" dirty="0" err="1"/>
-              <a:t>infrazioni</a:t>
-            </a:r>
-            <a:r>
-              <a:rPr lang="en-US" dirty="0"/>
-              <a:t>.</a:t>
-            </a:r>
-          </a:p>
-          <a:p>
-            <a:endParaRPr lang="en-US" dirty="0"/>
-          </a:p>
-          <a:p>
-            <a:r>
-              <a:rPr lang="en-US" dirty="0" err="1"/>
-              <a:t>Creato</a:t>
-            </a:r>
-            <a:r>
-              <a:rPr lang="en-US" dirty="0"/>
-              <a:t> la Colonna </a:t>
-            </a:r>
-            <a:r>
-              <a:rPr lang="en-US" dirty="0" err="1"/>
-              <a:t>superamento</a:t>
-            </a:r>
-            <a:r>
-              <a:rPr lang="en-US" dirty="0"/>
-              <a:t> (</a:t>
-            </a:r>
-            <a:r>
-              <a:rPr lang="en-US" dirty="0" err="1"/>
-              <a:t>booleana</a:t>
-            </a:r>
-            <a:r>
-              <a:rPr lang="en-US" dirty="0"/>
-              <a:t>) se la </a:t>
-            </a:r>
-            <a:r>
-              <a:rPr lang="en-US" dirty="0" err="1"/>
-              <a:t>velocita</a:t>
-            </a:r>
-            <a:r>
-              <a:rPr lang="en-US" dirty="0"/>
-              <a:t> </a:t>
-            </a:r>
-            <a:r>
-              <a:rPr lang="en-US" dirty="0" err="1"/>
-              <a:t>è</a:t>
-            </a:r>
-            <a:r>
-              <a:rPr lang="en-US" dirty="0"/>
-              <a:t> Maggiore della zona </a:t>
-            </a:r>
-            <a:r>
-              <a:rPr lang="en-US" dirty="0" err="1"/>
-              <a:t>limite</a:t>
-            </a:r>
-            <a:r>
-              <a:rPr lang="en-US" dirty="0"/>
-              <a:t>, e poi </a:t>
-            </a:r>
-            <a:r>
-              <a:rPr lang="en-US" dirty="0" err="1"/>
-              <a:t>semplicemente</a:t>
-            </a:r>
-            <a:r>
-              <a:rPr lang="en-US" dirty="0"/>
-              <a:t> </a:t>
-            </a:r>
-            <a:r>
-              <a:rPr lang="en-US" dirty="0" err="1"/>
-              <a:t>raggruppiamo</a:t>
-            </a:r>
-            <a:r>
-              <a:rPr lang="en-US" dirty="0"/>
-              <a:t> per </a:t>
-            </a:r>
-            <a:r>
-              <a:rPr lang="en-US" dirty="0" err="1"/>
-              <a:t>lat</a:t>
-            </a:r>
-            <a:r>
-              <a:rPr lang="en-US" dirty="0"/>
-              <a:t> e </a:t>
-            </a:r>
-            <a:r>
-              <a:rPr lang="en-US" dirty="0" err="1"/>
-              <a:t>lon</a:t>
-            </a:r>
-            <a:r>
-              <a:rPr lang="en-US" dirty="0"/>
-              <a:t> (</a:t>
-            </a:r>
-            <a:r>
-              <a:rPr lang="en-US" dirty="0" err="1"/>
-              <a:t>quindi</a:t>
-            </a:r>
-            <a:r>
-              <a:rPr lang="en-US" dirty="0"/>
-              <a:t> per ogni radar) e </a:t>
-            </a:r>
-            <a:r>
-              <a:rPr lang="en-US" dirty="0" err="1"/>
-              <a:t>calcoliamo</a:t>
-            </a:r>
-            <a:r>
-              <a:rPr lang="en-US" dirty="0"/>
-              <a:t> per ogni radar il </a:t>
-            </a:r>
-            <a:r>
-              <a:rPr lang="en-US" dirty="0" err="1"/>
-              <a:t>numero</a:t>
-            </a:r>
-            <a:r>
-              <a:rPr lang="en-US" dirty="0"/>
-              <a:t> di </a:t>
-            </a:r>
-            <a:r>
-              <a:rPr lang="en-US" dirty="0" err="1"/>
-              <a:t>registrazioni</a:t>
-            </a:r>
-            <a:r>
-              <a:rPr lang="en-US" dirty="0"/>
-              <a:t> e il </a:t>
-            </a:r>
-            <a:r>
-              <a:rPr lang="en-US" dirty="0" err="1"/>
-              <a:t>numero</a:t>
-            </a:r>
-            <a:r>
-              <a:rPr lang="en-US" dirty="0"/>
-              <a:t> di </a:t>
-            </a:r>
-            <a:r>
-              <a:rPr lang="en-US" dirty="0" err="1"/>
-              <a:t>superamenti</a:t>
-            </a:r>
-            <a:endParaRPr lang="en-US" dirty="0"/>
-          </a:p>
-          <a:p>
-            <a:endParaRPr lang="en-US" dirty="0"/>
-          </a:p>
-          <a:p>
-            <a:r>
-              <a:rPr lang="en-US" dirty="0" err="1"/>
-              <a:t>Cambiamenti</a:t>
-            </a:r>
-            <a:r>
-              <a:rPr lang="en-US" dirty="0"/>
-              <a:t>:</a:t>
-            </a:r>
-          </a:p>
-          <a:p>
-            <a:r>
-              <a:rPr lang="en-US" dirty="0" err="1"/>
-              <a:t>implica</a:t>
-            </a:r>
-            <a:r>
-              <a:rPr lang="en-US" dirty="0"/>
-              <a:t> il </a:t>
-            </a:r>
-            <a:r>
-              <a:rPr lang="en-US" dirty="0" err="1"/>
-              <a:t>fatto</a:t>
-            </a:r>
-            <a:r>
-              <a:rPr lang="en-US" dirty="0"/>
-              <a:t> </a:t>
-            </a:r>
-            <a:r>
-              <a:rPr lang="en-US" dirty="0" err="1"/>
-              <a:t>che</a:t>
-            </a:r>
-            <a:r>
-              <a:rPr lang="en-US" dirty="0"/>
-              <a:t> </a:t>
-            </a:r>
-            <a:r>
-              <a:rPr lang="en-US" dirty="0" err="1"/>
-              <a:t>siano</a:t>
-            </a:r>
-            <a:r>
-              <a:rPr lang="en-US" dirty="0"/>
-              <a:t> </a:t>
-            </a:r>
-            <a:r>
-              <a:rPr lang="en-US" dirty="0" err="1"/>
-              <a:t>accesi</a:t>
-            </a:r>
-            <a:r>
-              <a:rPr lang="en-US" dirty="0"/>
-              <a:t> sempre (</a:t>
-            </a:r>
-            <a:r>
-              <a:rPr lang="en-US" dirty="0" err="1"/>
-              <a:t>verificare</a:t>
-            </a:r>
-            <a:r>
-              <a:rPr lang="en-US" dirty="0"/>
-              <a:t>)</a:t>
-            </a:r>
-          </a:p>
-          <a:p>
-            <a:r>
-              <a:rPr lang="en-US" dirty="0" err="1"/>
-              <a:t>cambiare</a:t>
-            </a:r>
-            <a:r>
-              <a:rPr lang="en-US" dirty="0"/>
-              <a:t> il </a:t>
-            </a:r>
-            <a:r>
-              <a:rPr lang="en-US" dirty="0" err="1"/>
-              <a:t>numero</a:t>
-            </a:r>
-            <a:r>
-              <a:rPr lang="en-US" dirty="0"/>
-              <a:t> di </a:t>
-            </a:r>
-            <a:r>
-              <a:rPr lang="en-US" dirty="0" err="1"/>
-              <a:t>infrazioni</a:t>
-            </a:r>
-            <a:r>
-              <a:rPr lang="en-US" dirty="0"/>
-              <a:t> con il TASSO DI INFRAZIONE in </a:t>
-            </a:r>
-            <a:r>
-              <a:rPr lang="en-US" dirty="0" err="1"/>
-              <a:t>percentuale</a:t>
-            </a:r>
-            <a:r>
-              <a:rPr lang="en-US" dirty="0"/>
-              <a:t>.</a:t>
+              <a:rPr lang="it-CH" b="1" dirty="0"/>
+              <a:t>Domanda di ricerca:</a:t>
+            </a:r>
+            <a:r>
+              <a:rPr lang="it-CH" dirty="0"/>
+              <a:t> Un maggior volume di traffico comporta un tasso più alto di infrazioni?</a:t>
+            </a:r>
+          </a:p>
+          <a:p>
+            <a:r>
+              <a:rPr lang="it-CH" b="1" dirty="0"/>
+              <a:t>Visualizzazione:</a:t>
+            </a:r>
+            <a:endParaRPr lang="it-CH" dirty="0"/>
+          </a:p>
+          <a:p>
+            <a:pPr lvl="1"/>
+            <a:r>
+              <a:rPr lang="it-CH" b="1" dirty="0"/>
+              <a:t>Dimensione:</a:t>
+            </a:r>
+            <a:r>
+              <a:rPr lang="it-CH" dirty="0"/>
+              <a:t> Volume di traffico medio.</a:t>
+            </a:r>
+          </a:p>
+          <a:p>
+            <a:pPr lvl="1"/>
+            <a:r>
+              <a:rPr lang="it-CH" b="1" dirty="0"/>
+              <a:t>Colore:</a:t>
+            </a:r>
+            <a:r>
+              <a:rPr lang="it-CH" dirty="0"/>
+              <a:t> Tasso di infrazione (%).</a:t>
+            </a:r>
+          </a:p>
+          <a:p>
+            <a:r>
+              <a:rPr lang="it-CH" b="1" dirty="0"/>
+              <a:t>Data Processing:</a:t>
+            </a:r>
+            <a:r>
+              <a:rPr lang="it-CH" dirty="0"/>
+              <a:t> * Creazione di una colonna booleana per identificare i superamenti del limite.</a:t>
+            </a:r>
+          </a:p>
+          <a:p>
+            <a:pPr lvl="1"/>
+            <a:r>
+              <a:rPr lang="it-CH" dirty="0"/>
+              <a:t>Aggregazione dei dati per postazione (latitudine/longitudine) per calcolare transiti totali e infrazioni effettive.</a:t>
             </a:r>
           </a:p>
         </p:txBody>
@@ -4646,7 +3879,7 @@
               <a:buNone/>
             </a:pPr>
             <a:r>
-              <a:rPr lang="en-US" sz="2200" b="1" dirty="0">
+              <a:rPr lang="en-US" sz="2200" b="1" dirty="0" err="1">
                 <a:solidFill>
                   <a:srgbClr val="00B4D8"/>
                 </a:solidFill>
@@ -4654,7 +3887,7 @@
                 <a:ea typeface="Calibri" pitchFamily="34" charset="-122"/>
                 <a:cs typeface="Calibri" pitchFamily="34" charset="-120"/>
               </a:rPr>
-              <a:t>Conclusioni &amp; Prossimi Passi</a:t>
+              <a:t>Conclusioni</a:t>
             </a:r>
             <a:endParaRPr lang="en-US" sz="2200" dirty="0"/>
           </a:p>
@@ -5012,52 +4245,6 @@
               <a:ea typeface="Calibri" pitchFamily="34" charset="-122"/>
               <a:cs typeface="Calibri" pitchFamily="34" charset="-120"/>
             </a:endParaRPr>
-          </a:p>
-          <a:p>
-            <a:r>
-              <a:rPr lang="en-US" sz="2400" i="1" dirty="0" err="1">
-                <a:solidFill>
-                  <a:srgbClr val="B0BEC5"/>
-                </a:solidFill>
-                <a:latin typeface="Calibri" pitchFamily="34" charset="0"/>
-                <a:ea typeface="Calibri" pitchFamily="34" charset="-122"/>
-                <a:cs typeface="Calibri" pitchFamily="34" charset="-120"/>
-              </a:rPr>
-              <a:t>Prossimo</a:t>
-            </a:r>
-            <a:r>
-              <a:rPr lang="en-US" sz="2400" i="1" dirty="0">
-                <a:solidFill>
-                  <a:srgbClr val="B0BEC5"/>
-                </a:solidFill>
-                <a:latin typeface="Calibri" pitchFamily="34" charset="0"/>
-                <a:ea typeface="Calibri" pitchFamily="34" charset="-122"/>
-                <a:cs typeface="Calibri" pitchFamily="34" charset="-120"/>
-              </a:rPr>
-              <a:t> step: </a:t>
-            </a:r>
-            <a:r>
-              <a:rPr lang="en-US" sz="2400" i="1" dirty="0" err="1">
-                <a:solidFill>
-                  <a:srgbClr val="B0BEC5"/>
-                </a:solidFill>
-                <a:latin typeface="Calibri" pitchFamily="34" charset="0"/>
-                <a:ea typeface="Calibri" pitchFamily="34" charset="-122"/>
-                <a:cs typeface="Calibri" pitchFamily="34" charset="-120"/>
-              </a:rPr>
-              <a:t>presentazione</a:t>
-            </a:r>
-            <a:r>
-              <a:rPr lang="en-US" sz="2400" i="1" dirty="0">
-                <a:solidFill>
-                  <a:srgbClr val="B0BEC5"/>
-                </a:solidFill>
-                <a:latin typeface="Calibri" pitchFamily="34" charset="0"/>
-                <a:ea typeface="Calibri" pitchFamily="34" charset="-122"/>
-                <a:cs typeface="Calibri" pitchFamily="34" charset="-120"/>
-              </a:rPr>
-              <a:t> finale.</a:t>
-            </a:r>
           </a:p>
         </p:txBody>
       </p:sp>
@@ -6260,7 +5447,7 @@
 </file>
 
 <file path=ppt/slides/slide3.xml><?xml version="1.0" encoding="utf-8"?>
-<p:sld xmlns:a="http://schemas.openxmlformats.org/drawingml/2006/main" xmlns:r="http://schemas.openxmlformats.org/officeDocument/2006/relationships" xmlns:p="http://schemas.openxmlformats.org/presentationml/2006/main" show="0">
+<p:sld xmlns:a="http://schemas.openxmlformats.org/drawingml/2006/main" xmlns:r="http://schemas.openxmlformats.org/officeDocument/2006/relationships" xmlns:p="http://schemas.openxmlformats.org/presentationml/2006/main">
   <p:cSld name="Slide 5">
     <p:bg>
       <p:bgPr>
@@ -7011,7 +6198,7 @@
 </file>
 
 <file path=ppt/slides/slide5.xml><?xml version="1.0" encoding="utf-8"?>
-<p:sld xmlns:a="http://schemas.openxmlformats.org/drawingml/2006/main" xmlns:r="http://schemas.openxmlformats.org/officeDocument/2006/relationships" xmlns:p="http://schemas.openxmlformats.org/presentationml/2006/main" show="0">
+<p:sld xmlns:a="http://schemas.openxmlformats.org/drawingml/2006/main" xmlns:r="http://schemas.openxmlformats.org/officeDocument/2006/relationships" xmlns:p="http://schemas.openxmlformats.org/presentationml/2006/main">
   <p:cSld name="Slide 6">
     <p:bg>
       <p:bgPr>
@@ -7652,10 +6839,10 @@
       </p:sp>
       <p:pic>
         <p:nvPicPr>
-          <p:cNvPr id="8" name="Immagine 7">
+          <p:cNvPr id="15" name="Immagine 14">
             <a:extLst>
               <a:ext uri="{FF2B5EF4-FFF2-40B4-BE49-F238E27FC236}">
-                <a16:creationId xmlns:a16="http://schemas.microsoft.com/office/drawing/2014/main" id="{52666C92-5D98-E046-EBED-A16FFCCE3489}"/>
+                <a16:creationId xmlns:a16="http://schemas.microsoft.com/office/drawing/2014/main" id="{5762F2DA-EE19-5F78-49A8-DA3EFAB02088}"/>
               </a:ext>
             </a:extLst>
           </p:cNvPr>
@@ -7672,8 +6859,8 @@
         </p:blipFill>
         <p:spPr>
           <a:xfrm>
-            <a:off x="365759" y="1216152"/>
-            <a:ext cx="8503919" cy="3700022"/>
+            <a:off x="365760" y="1234440"/>
+            <a:ext cx="8538994" cy="3611880"/>
           </a:xfrm>
           <a:prstGeom prst="rect">
             <a:avLst/>
@@ -8105,10 +7292,10 @@
       </p:sp>
       <p:pic>
         <p:nvPicPr>
-          <p:cNvPr id="12" name="Picture 11">
+          <p:cNvPr id="8" name="Immagine 7">
             <a:extLst>
               <a:ext uri="{FF2B5EF4-FFF2-40B4-BE49-F238E27FC236}">
-                <a16:creationId xmlns:a16="http://schemas.microsoft.com/office/drawing/2014/main" id="{75A0428F-07FB-377E-BE60-D38973DC1DF0}"/>
+                <a16:creationId xmlns:a16="http://schemas.microsoft.com/office/drawing/2014/main" id="{53C93D34-601C-CDD8-C82D-950B1F8474E7}"/>
               </a:ext>
             </a:extLst>
           </p:cNvPr>
@@ -8125,8 +7312,8 @@
         </p:blipFill>
         <p:spPr>
           <a:xfrm>
-            <a:off x="377918" y="1447800"/>
-            <a:ext cx="8479604" cy="3185160"/>
+            <a:off x="365760" y="1234440"/>
+            <a:ext cx="8538994" cy="3611880"/>
           </a:xfrm>
           <a:prstGeom prst="rect">
             <a:avLst/>
@@ -8680,7 +7867,7 @@
 </file>
 
 <file path=ppt/slides/slide9.xml><?xml version="1.0" encoding="utf-8"?>
-<p:sld xmlns:a="http://schemas.openxmlformats.org/drawingml/2006/main" xmlns:r="http://schemas.openxmlformats.org/officeDocument/2006/relationships" xmlns:p="http://schemas.openxmlformats.org/presentationml/2006/main">
+<p:sld xmlns:a="http://schemas.openxmlformats.org/drawingml/2006/main" xmlns:r="http://schemas.openxmlformats.org/officeDocument/2006/relationships" xmlns:p="http://schemas.openxmlformats.org/presentationml/2006/main" show="0">
   <p:cSld name="Slide 8">
     <p:bg>
       <p:bgPr>

</xml_diff>

<commit_message>
Modifiche presentazione e grafici
</commit_message>
<xml_diff>
--- a/speed_monitoring.pptx
+++ b/speed_monitoring.pptx
@@ -5,7 +5,7 @@
     <p:sldMasterId id="2147483648" r:id="rId1"/>
   </p:sldMasterIdLst>
   <p:notesMasterIdLst>
-    <p:notesMasterId r:id="rId12"/>
+    <p:notesMasterId r:id="rId13"/>
   </p:notesMasterIdLst>
   <p:sldIdLst>
     <p:sldId id="256" r:id="rId2"/>
@@ -14,10 +14,11 @@
     <p:sldId id="265" r:id="rId5"/>
     <p:sldId id="261" r:id="rId6"/>
     <p:sldId id="268" r:id="rId7"/>
-    <p:sldId id="266" r:id="rId8"/>
-    <p:sldId id="267" r:id="rId9"/>
-    <p:sldId id="263" r:id="rId10"/>
-    <p:sldId id="264" r:id="rId11"/>
+    <p:sldId id="269" r:id="rId8"/>
+    <p:sldId id="266" r:id="rId9"/>
+    <p:sldId id="267" r:id="rId10"/>
+    <p:sldId id="263" r:id="rId11"/>
+    <p:sldId id="264" r:id="rId12"/>
   </p:sldIdLst>
   <p:sldSz cx="9144000" cy="5143500" type="screen16x9"/>
   <p:notesSz cx="5143500" cy="9144000"/>
@@ -374,6 +375,139 @@
           <a:bodyPr/>
           <a:lstStyle/>
           <a:p>
+            <a:r>
+              <a:rPr lang="en-US" dirty="0" err="1"/>
+              <a:t>Guardare</a:t>
+            </a:r>
+            <a:r>
+              <a:rPr lang="en-US" dirty="0"/>
+              <a:t> heatmap: </a:t>
+            </a:r>
+            <a:r>
+              <a:rPr lang="en-US" dirty="0" err="1"/>
+              <a:t>strano</a:t>
+            </a:r>
+            <a:r>
+              <a:rPr lang="en-US" dirty="0"/>
+              <a:t> </a:t>
+            </a:r>
+            <a:r>
+              <a:rPr lang="en-US" dirty="0" err="1"/>
+              <a:t>che</a:t>
+            </a:r>
+            <a:r>
+              <a:rPr lang="en-US" dirty="0"/>
+              <a:t> </a:t>
+            </a:r>
+            <a:r>
+              <a:rPr lang="en-US" dirty="0" err="1"/>
+              <a:t>c'è</a:t>
+            </a:r>
+            <a:r>
+              <a:rPr lang="en-US" dirty="0"/>
+              <a:t> </a:t>
+            </a:r>
+            <a:r>
+              <a:rPr lang="en-US" dirty="0" err="1"/>
+              <a:t>più</a:t>
+            </a:r>
+            <a:r>
+              <a:rPr lang="en-US" dirty="0"/>
+              <a:t> </a:t>
+            </a:r>
+            <a:r>
+              <a:rPr lang="en-US" dirty="0" err="1"/>
+              <a:t>traffico</a:t>
+            </a:r>
+            <a:r>
+              <a:rPr lang="en-US" dirty="0"/>
+              <a:t> alle 15 rispetto alle 17</a:t>
+            </a:r>
+            <a:br>
+              <a:rPr lang="en-US" dirty="0"/>
+            </a:br>
+            <a:br>
+              <a:rPr lang="en-US" dirty="0"/>
+            </a:br>
+            <a:r>
+              <a:rPr lang="en-US" dirty="0"/>
+              <a:t>Esempio Di notte non </a:t>
+            </a:r>
+            <a:r>
+              <a:rPr lang="en-US" dirty="0" err="1"/>
+              <a:t>c'è</a:t>
+            </a:r>
+            <a:r>
+              <a:rPr lang="en-US" dirty="0"/>
+              <a:t> il radar </a:t>
+            </a:r>
+            <a:r>
+              <a:rPr lang="en-US" dirty="0" err="1"/>
+              <a:t>nella</a:t>
+            </a:r>
+            <a:r>
+              <a:rPr lang="en-US" dirty="0"/>
+              <a:t> </a:t>
+            </a:r>
+            <a:r>
+              <a:rPr lang="en-US" dirty="0" err="1"/>
+              <a:t>stradina</a:t>
+            </a:r>
+            <a:r>
+              <a:rPr lang="en-US" dirty="0"/>
+              <a:t> di </a:t>
+            </a:r>
+            <a:r>
+              <a:rPr lang="en-US" dirty="0" err="1"/>
+              <a:t>paese</a:t>
+            </a:r>
+            <a:r>
+              <a:rPr lang="en-US" dirty="0"/>
+              <a:t> ma </a:t>
+            </a:r>
+            <a:r>
+              <a:rPr lang="en-US" dirty="0" err="1"/>
+              <a:t>nelle</a:t>
+            </a:r>
+            <a:r>
+              <a:rPr lang="en-US" dirty="0"/>
+              <a:t> </a:t>
+            </a:r>
+            <a:r>
+              <a:rPr lang="en-US" dirty="0" err="1"/>
+              <a:t>strade</a:t>
+            </a:r>
+            <a:r>
+              <a:rPr lang="en-US" dirty="0"/>
+              <a:t> </a:t>
+            </a:r>
+            <a:r>
+              <a:rPr lang="en-US" dirty="0" err="1"/>
+              <a:t>veloci</a:t>
+            </a:r>
+            <a:r>
+              <a:rPr lang="en-US" dirty="0"/>
+              <a:t>?</a:t>
+            </a:r>
+            <a:br>
+              <a:rPr lang="en-US" dirty="0"/>
+            </a:br>
+            <a:r>
+              <a:rPr lang="en-US" dirty="0"/>
+              <a:t>Vedi se </a:t>
+            </a:r>
+            <a:r>
+              <a:rPr lang="en-US" dirty="0" err="1"/>
+              <a:t>è</a:t>
+            </a:r>
+            <a:r>
+              <a:rPr lang="en-US" dirty="0"/>
+              <a:t> </a:t>
+            </a:r>
+            <a:r>
+              <a:rPr lang="en-US" dirty="0" err="1"/>
+              <a:t>vero</a:t>
+            </a:r>
             <a:endParaRPr lang="en-US" dirty="0"/>
           </a:p>
         </p:txBody>
@@ -396,6 +530,90 @@
             <a:fld id="{F7021451-1387-4CA6-816F-3879F97B5CBC}" type="slidenum">
               <a:rPr lang="en-US"/>
               <a:t>10</a:t>
+            </a:fld>
+            <a:endParaRPr lang="en-US"/>
+          </a:p>
+        </p:txBody>
+      </p:sp>
+    </p:spTree>
+    <p:extLst>
+      <p:ext uri="{BB962C8B-B14F-4D97-AF65-F5344CB8AC3E}">
+        <p14:creationId xmlns:p14="http://schemas.microsoft.com/office/powerpoint/2010/main" val="1024086991"/>
+      </p:ext>
+    </p:extLst>
+  </p:cSld>
+  <p:clrMapOvr>
+    <a:masterClrMapping/>
+  </p:clrMapOvr>
+</p:notes>
+</file>
+
+<file path=ppt/notesSlides/notesSlide11.xml><?xml version="1.0" encoding="utf-8"?>
+<p:notes xmlns:a="http://schemas.openxmlformats.org/drawingml/2006/main" xmlns:r="http://schemas.openxmlformats.org/officeDocument/2006/relationships" xmlns:p="http://schemas.openxmlformats.org/presentationml/2006/main">
+  <p:cSld>
+    <p:spTree>
+      <p:nvGrpSpPr>
+        <p:cNvPr id="1" name=""/>
+        <p:cNvGrpSpPr/>
+        <p:nvPr/>
+      </p:nvGrpSpPr>
+      <p:grpSpPr>
+        <a:xfrm>
+          <a:off x="0" y="0"/>
+          <a:ext cx="0" cy="0"/>
+          <a:chOff x="0" y="0"/>
+          <a:chExt cx="0" cy="0"/>
+        </a:xfrm>
+      </p:grpSpPr>
+      <p:sp>
+        <p:nvSpPr>
+          <p:cNvPr id="2" name="Slide Image Placeholder 1"/>
+          <p:cNvSpPr>
+            <a:spLocks noGrp="1" noRot="1" noChangeAspect="1"/>
+          </p:cNvSpPr>
+          <p:nvPr>
+            <p:ph type="sldImg"/>
+          </p:nvPr>
+        </p:nvSpPr>
+        <p:spPr/>
+      </p:sp>
+      <p:sp>
+        <p:nvSpPr>
+          <p:cNvPr id="3" name="Notes Placeholder 2"/>
+          <p:cNvSpPr>
+            <a:spLocks noGrp="1"/>
+          </p:cNvSpPr>
+          <p:nvPr>
+            <p:ph type="body" idx="1"/>
+          </p:nvPr>
+        </p:nvSpPr>
+        <p:spPr/>
+        <p:txBody>
+          <a:bodyPr/>
+          <a:lstStyle/>
+          <a:p>
+            <a:endParaRPr lang="en-US" dirty="0"/>
+          </a:p>
+        </p:txBody>
+      </p:sp>
+      <p:sp>
+        <p:nvSpPr>
+          <p:cNvPr id="4" name="Slide Number Placeholder 3"/>
+          <p:cNvSpPr>
+            <a:spLocks noGrp="1"/>
+          </p:cNvSpPr>
+          <p:nvPr>
+            <p:ph type="sldNum" sz="quarter" idx="10"/>
+          </p:nvPr>
+        </p:nvSpPr>
+        <p:spPr/>
+        <p:txBody>
+          <a:bodyPr/>
+          <a:lstStyle/>
+          <a:p>
+            <a:fld id="{F7021451-1387-4CA6-816F-3879F97B5CBC}" type="slidenum">
+              <a:rPr lang="en-US"/>
+              <a:t>11</a:t>
             </a:fld>
             <a:endParaRPr lang="en-US"/>
           </a:p>
@@ -1724,6 +1942,62 @@
             </a:r>
             <a:r>
               <a:rPr lang="en-US" dirty="0"/>
+              <a:t> non </a:t>
+            </a:r>
+            <a:r>
+              <a:rPr lang="en-US" dirty="0" err="1"/>
+              <a:t>rappresenta</a:t>
+            </a:r>
+            <a:r>
+              <a:rPr lang="en-US" dirty="0"/>
+              <a:t> il </a:t>
+            </a:r>
+            <a:r>
+              <a:rPr lang="en-US" dirty="0" err="1"/>
+              <a:t>numero</a:t>
+            </a:r>
+            <a:r>
+              <a:rPr lang="en-US" dirty="0"/>
+              <a:t> </a:t>
+            </a:r>
+            <a:r>
+              <a:rPr lang="en-US" dirty="0" err="1"/>
+              <a:t>effettivo</a:t>
+            </a:r>
+            <a:r>
+              <a:rPr lang="en-US" dirty="0"/>
+              <a:t> di auto ma solo le </a:t>
+            </a:r>
+            <a:r>
+              <a:rPr lang="en-US" dirty="0" err="1"/>
+              <a:t>misurazioni</a:t>
+            </a:r>
+            <a:r>
+              <a:rPr lang="en-US" dirty="0"/>
+              <a:t> </a:t>
+            </a:r>
+            <a:r>
+              <a:rPr lang="en-US" dirty="0" err="1"/>
+              <a:t>quindi</a:t>
+            </a:r>
+            <a:r>
+              <a:rPr lang="en-US" dirty="0"/>
+              <a:t> </a:t>
+            </a:r>
+            <a:r>
+              <a:rPr lang="en-US" dirty="0" err="1"/>
+              <a:t>significa</a:t>
+            </a:r>
+            <a:r>
+              <a:rPr lang="en-US" dirty="0"/>
+              <a:t> ”</a:t>
+            </a:r>
+            <a:r>
+              <a:rPr lang="en-US" dirty="0" err="1"/>
+              <a:t>quando</a:t>
+            </a:r>
+            <a:r>
+              <a:rPr lang="en-US" dirty="0"/>
               <a:t> ci </a:t>
             </a:r>
             <a:r>
@@ -1748,39 +2022,7 @@
             </a:r>
             <a:r>
               <a:rPr lang="en-US" dirty="0"/>
-              <a:t> in </a:t>
-            </a:r>
-            <a:r>
-              <a:rPr lang="en-US" dirty="0" err="1"/>
-              <a:t>strade</a:t>
-            </a:r>
-            <a:r>
-              <a:rPr lang="en-US" dirty="0"/>
-              <a:t> </a:t>
-            </a:r>
-            <a:r>
-              <a:rPr lang="en-US" dirty="0" err="1"/>
-              <a:t>cantonali</a:t>
-            </a:r>
-            <a:r>
-              <a:rPr lang="en-US" dirty="0"/>
-              <a:t> </a:t>
-            </a:r>
-            <a:r>
-              <a:rPr lang="en-US" dirty="0" err="1"/>
-              <a:t>ecc</a:t>
-            </a:r>
-            <a:r>
-              <a:rPr lang="en-US" dirty="0"/>
-              <a:t>. e non solo in </a:t>
-            </a:r>
-            <a:r>
-              <a:rPr lang="en-US" dirty="0" err="1"/>
-              <a:t>stradine</a:t>
-            </a:r>
-            <a:r>
-              <a:rPr lang="en-US" dirty="0"/>
-              <a:t> lente (30kmh)</a:t>
+              <a:t>”</a:t>
             </a:r>
           </a:p>
         </p:txBody>
@@ -1937,6 +2179,235 @@
         <p:cNvPr id="1" name="">
           <a:extLst>
             <a:ext uri="{FF2B5EF4-FFF2-40B4-BE49-F238E27FC236}">
+              <a16:creationId xmlns:a16="http://schemas.microsoft.com/office/drawing/2014/main" id="{77B3D618-3A3E-E7CA-57C8-5D88E0916BF5}"/>
+            </a:ext>
+          </a:extLst>
+        </p:cNvPr>
+        <p:cNvGrpSpPr/>
+        <p:nvPr/>
+      </p:nvGrpSpPr>
+      <p:grpSpPr>
+        <a:xfrm>
+          <a:off x="0" y="0"/>
+          <a:ext cx="0" cy="0"/>
+          <a:chOff x="0" y="0"/>
+          <a:chExt cx="0" cy="0"/>
+        </a:xfrm>
+      </p:grpSpPr>
+      <p:sp>
+        <p:nvSpPr>
+          <p:cNvPr id="2" name="Slide Image Placeholder 1">
+            <a:extLst>
+              <a:ext uri="{FF2B5EF4-FFF2-40B4-BE49-F238E27FC236}">
+                <a16:creationId xmlns:a16="http://schemas.microsoft.com/office/drawing/2014/main" id="{BAFC2154-C247-753E-75D9-E76062F321D4}"/>
+              </a:ext>
+            </a:extLst>
+          </p:cNvPr>
+          <p:cNvSpPr>
+            <a:spLocks noGrp="1" noRot="1" noChangeAspect="1"/>
+          </p:cNvSpPr>
+          <p:nvPr>
+            <p:ph type="sldImg"/>
+          </p:nvPr>
+        </p:nvSpPr>
+        <p:spPr/>
+      </p:sp>
+      <p:sp>
+        <p:nvSpPr>
+          <p:cNvPr id="3" name="Notes Placeholder 2">
+            <a:extLst>
+              <a:ext uri="{FF2B5EF4-FFF2-40B4-BE49-F238E27FC236}">
+                <a16:creationId xmlns:a16="http://schemas.microsoft.com/office/drawing/2014/main" id="{1D798DA0-4188-BB68-C0B3-25528370A28A}"/>
+              </a:ext>
+            </a:extLst>
+          </p:cNvPr>
+          <p:cNvSpPr>
+            <a:spLocks noGrp="1"/>
+          </p:cNvSpPr>
+          <p:nvPr>
+            <p:ph type="body" idx="1"/>
+          </p:nvPr>
+        </p:nvSpPr>
+        <p:spPr/>
+        <p:txBody>
+          <a:bodyPr/>
+          <a:lstStyle/>
+          <a:p>
+            <a:r>
+              <a:rPr lang="en-US" dirty="0" err="1"/>
+              <a:t>Sembra</a:t>
+            </a:r>
+            <a:r>
+              <a:rPr lang="en-US" dirty="0"/>
+              <a:t> </a:t>
+            </a:r>
+            <a:r>
+              <a:rPr lang="en-US" dirty="0" err="1"/>
+              <a:t>strano</a:t>
+            </a:r>
+            <a:r>
+              <a:rPr lang="en-US" dirty="0"/>
+              <a:t> </a:t>
+            </a:r>
+            <a:r>
+              <a:rPr lang="en-US" dirty="0" err="1"/>
+              <a:t>che</a:t>
+            </a:r>
+            <a:r>
+              <a:rPr lang="en-US" dirty="0"/>
+              <a:t> </a:t>
+            </a:r>
+            <a:r>
+              <a:rPr lang="en-US" dirty="0" err="1"/>
+              <a:t>c'è</a:t>
+            </a:r>
+            <a:r>
+              <a:rPr lang="en-US" dirty="0"/>
+              <a:t> </a:t>
+            </a:r>
+            <a:r>
+              <a:rPr lang="en-US" dirty="0" err="1"/>
+              <a:t>più</a:t>
+            </a:r>
+            <a:r>
+              <a:rPr lang="en-US" dirty="0"/>
+              <a:t> </a:t>
+            </a:r>
+            <a:r>
+              <a:rPr lang="en-US" dirty="0" err="1"/>
+              <a:t>traffico</a:t>
+            </a:r>
+            <a:r>
+              <a:rPr lang="en-US" dirty="0"/>
+              <a:t> alle 15 rispetto alle 17</a:t>
+            </a:r>
+          </a:p>
+          <a:p>
+            <a:r>
+              <a:rPr lang="en-US" dirty="0" err="1"/>
+              <a:t>Semplicemente</a:t>
+            </a:r>
+            <a:r>
+              <a:rPr lang="en-US" dirty="0"/>
+              <a:t> </a:t>
+            </a:r>
+            <a:r>
+              <a:rPr lang="en-US" dirty="0" err="1"/>
+              <a:t>perché</a:t>
+            </a:r>
+            <a:r>
+              <a:rPr lang="en-US" dirty="0"/>
+              <a:t> ci </a:t>
+            </a:r>
+            <a:r>
+              <a:rPr lang="en-US" dirty="0" err="1"/>
+              <a:t>sono</a:t>
+            </a:r>
+            <a:r>
+              <a:rPr lang="en-US" dirty="0"/>
+              <a:t> </a:t>
+            </a:r>
+            <a:r>
+              <a:rPr lang="en-US" dirty="0" err="1"/>
+              <a:t>più</a:t>
+            </a:r>
+            <a:r>
+              <a:rPr lang="en-US" dirty="0"/>
+              <a:t> </a:t>
+            </a:r>
+            <a:r>
+              <a:rPr lang="en-US" dirty="0" err="1"/>
+              <a:t>controlli</a:t>
+            </a:r>
+            <a:r>
+              <a:rPr lang="en-US" dirty="0"/>
+              <a:t> in </a:t>
+            </a:r>
+            <a:r>
+              <a:rPr lang="en-US" dirty="0" err="1"/>
+              <a:t>strade</a:t>
+            </a:r>
+            <a:r>
+              <a:rPr lang="en-US" dirty="0"/>
+              <a:t> </a:t>
+            </a:r>
+            <a:r>
+              <a:rPr lang="en-US" dirty="0" err="1"/>
+              <a:t>cantonali</a:t>
+            </a:r>
+            <a:r>
+              <a:rPr lang="en-US" dirty="0"/>
+              <a:t> </a:t>
+            </a:r>
+            <a:r>
+              <a:rPr lang="en-US" dirty="0" err="1"/>
+              <a:t>ecc</a:t>
+            </a:r>
+            <a:r>
+              <a:rPr lang="en-US" dirty="0"/>
+              <a:t>. e non solo in </a:t>
+            </a:r>
+            <a:r>
+              <a:rPr lang="en-US" dirty="0" err="1"/>
+              <a:t>stradine</a:t>
+            </a:r>
+            <a:r>
+              <a:rPr lang="en-US" dirty="0"/>
+              <a:t> lente (30kmh)</a:t>
+            </a:r>
+          </a:p>
+        </p:txBody>
+      </p:sp>
+      <p:sp>
+        <p:nvSpPr>
+          <p:cNvPr id="4" name="Slide Number Placeholder 3">
+            <a:extLst>
+              <a:ext uri="{FF2B5EF4-FFF2-40B4-BE49-F238E27FC236}">
+                <a16:creationId xmlns:a16="http://schemas.microsoft.com/office/drawing/2014/main" id="{CE65B9D9-7B2C-D304-322D-8F6C92505ED1}"/>
+              </a:ext>
+            </a:extLst>
+          </p:cNvPr>
+          <p:cNvSpPr>
+            <a:spLocks noGrp="1"/>
+          </p:cNvSpPr>
+          <p:nvPr>
+            <p:ph type="sldNum" sz="quarter" idx="10"/>
+          </p:nvPr>
+        </p:nvSpPr>
+        <p:spPr/>
+        <p:txBody>
+          <a:bodyPr/>
+          <a:lstStyle/>
+          <a:p>
+            <a:fld id="{F7021451-1387-4CA6-816F-3879F97B5CBC}" type="slidenum">
+              <a:rPr lang="en-US"/>
+              <a:t>7</a:t>
+            </a:fld>
+            <a:endParaRPr lang="en-US"/>
+          </a:p>
+        </p:txBody>
+      </p:sp>
+    </p:spTree>
+    <p:extLst>
+      <p:ext uri="{BB962C8B-B14F-4D97-AF65-F5344CB8AC3E}">
+        <p14:creationId xmlns:p14="http://schemas.microsoft.com/office/powerpoint/2010/main" val="2911309874"/>
+      </p:ext>
+    </p:extLst>
+  </p:cSld>
+  <p:clrMapOvr>
+    <a:masterClrMapping/>
+  </p:clrMapOvr>
+</p:notes>
+</file>
+
+<file path=ppt/notesSlides/notesSlide8.xml><?xml version="1.0" encoding="utf-8"?>
+<p:notes xmlns:a="http://schemas.openxmlformats.org/drawingml/2006/main" xmlns:r="http://schemas.openxmlformats.org/officeDocument/2006/relationships" xmlns:p="http://schemas.openxmlformats.org/presentationml/2006/main">
+  <p:cSld>
+    <p:spTree>
+      <p:nvGrpSpPr>
+        <p:cNvPr id="1" name="">
+          <a:extLst>
+            <a:ext uri="{FF2B5EF4-FFF2-40B4-BE49-F238E27FC236}">
               <a16:creationId xmlns:a16="http://schemas.microsoft.com/office/drawing/2014/main" id="{5647EDB8-D8B2-21EF-B2E5-6E13FE4F8040}"/>
             </a:ext>
           </a:extLst>
@@ -2071,7 +2542,7 @@
           <a:p>
             <a:fld id="{F7021451-1387-4CA6-816F-3879F97B5CBC}" type="slidenum">
               <a:rPr lang="en-US"/>
-              <a:t>7</a:t>
+              <a:t>8</a:t>
             </a:fld>
             <a:endParaRPr lang="en-US"/>
           </a:p>
@@ -2090,7 +2561,7 @@
 </p:notes>
 </file>
 
-<file path=ppt/notesSlides/notesSlide8.xml><?xml version="1.0" encoding="utf-8"?>
+<file path=ppt/notesSlides/notesSlide9.xml><?xml version="1.0" encoding="utf-8"?>
 <p:notes xmlns:a="http://schemas.openxmlformats.org/drawingml/2006/main" xmlns:r="http://schemas.openxmlformats.org/officeDocument/2006/relationships" xmlns:p="http://schemas.openxmlformats.org/presentationml/2006/main">
   <p:cSld>
     <p:spTree>
@@ -2561,7 +3032,7 @@
           <a:p>
             <a:fld id="{F7021451-1387-4CA6-816F-3879F97B5CBC}" type="slidenum">
               <a:rPr lang="en-US"/>
-              <a:t>8</a:t>
+              <a:t>9</a:t>
             </a:fld>
             <a:endParaRPr lang="en-US"/>
           </a:p>
@@ -2571,223 +3042,6 @@
     <p:extLst>
       <p:ext uri="{BB962C8B-B14F-4D97-AF65-F5344CB8AC3E}">
         <p14:creationId xmlns:p14="http://schemas.microsoft.com/office/powerpoint/2010/main" val="3084976356"/>
-      </p:ext>
-    </p:extLst>
-  </p:cSld>
-  <p:clrMapOvr>
-    <a:masterClrMapping/>
-  </p:clrMapOvr>
-</p:notes>
-</file>
-
-<file path=ppt/notesSlides/notesSlide9.xml><?xml version="1.0" encoding="utf-8"?>
-<p:notes xmlns:a="http://schemas.openxmlformats.org/drawingml/2006/main" xmlns:r="http://schemas.openxmlformats.org/officeDocument/2006/relationships" xmlns:p="http://schemas.openxmlformats.org/presentationml/2006/main">
-  <p:cSld>
-    <p:spTree>
-      <p:nvGrpSpPr>
-        <p:cNvPr id="1" name=""/>
-        <p:cNvGrpSpPr/>
-        <p:nvPr/>
-      </p:nvGrpSpPr>
-      <p:grpSpPr>
-        <a:xfrm>
-          <a:off x="0" y="0"/>
-          <a:ext cx="0" cy="0"/>
-          <a:chOff x="0" y="0"/>
-          <a:chExt cx="0" cy="0"/>
-        </a:xfrm>
-      </p:grpSpPr>
-      <p:sp>
-        <p:nvSpPr>
-          <p:cNvPr id="2" name="Slide Image Placeholder 1"/>
-          <p:cNvSpPr>
-            <a:spLocks noGrp="1" noRot="1" noChangeAspect="1"/>
-          </p:cNvSpPr>
-          <p:nvPr>
-            <p:ph type="sldImg"/>
-          </p:nvPr>
-        </p:nvSpPr>
-        <p:spPr/>
-      </p:sp>
-      <p:sp>
-        <p:nvSpPr>
-          <p:cNvPr id="3" name="Notes Placeholder 2"/>
-          <p:cNvSpPr>
-            <a:spLocks noGrp="1"/>
-          </p:cNvSpPr>
-          <p:nvPr>
-            <p:ph type="body" idx="1"/>
-          </p:nvPr>
-        </p:nvSpPr>
-        <p:spPr/>
-        <p:txBody>
-          <a:bodyPr/>
-          <a:lstStyle/>
-          <a:p>
-            <a:r>
-              <a:rPr lang="en-US" dirty="0" err="1"/>
-              <a:t>Guardare</a:t>
-            </a:r>
-            <a:r>
-              <a:rPr lang="en-US" dirty="0"/>
-              <a:t> heatmap: </a:t>
-            </a:r>
-            <a:r>
-              <a:rPr lang="en-US" dirty="0" err="1"/>
-              <a:t>strano</a:t>
-            </a:r>
-            <a:r>
-              <a:rPr lang="en-US" dirty="0"/>
-              <a:t> </a:t>
-            </a:r>
-            <a:r>
-              <a:rPr lang="en-US" dirty="0" err="1"/>
-              <a:t>che</a:t>
-            </a:r>
-            <a:r>
-              <a:rPr lang="en-US" dirty="0"/>
-              <a:t> </a:t>
-            </a:r>
-            <a:r>
-              <a:rPr lang="en-US" dirty="0" err="1"/>
-              <a:t>c'è</a:t>
-            </a:r>
-            <a:r>
-              <a:rPr lang="en-US" dirty="0"/>
-              <a:t> </a:t>
-            </a:r>
-            <a:r>
-              <a:rPr lang="en-US" dirty="0" err="1"/>
-              <a:t>più</a:t>
-            </a:r>
-            <a:r>
-              <a:rPr lang="en-US" dirty="0"/>
-              <a:t> </a:t>
-            </a:r>
-            <a:r>
-              <a:rPr lang="en-US" dirty="0" err="1"/>
-              <a:t>traffico</a:t>
-            </a:r>
-            <a:r>
-              <a:rPr lang="en-US" dirty="0"/>
-              <a:t> alle 15 rispetto alle 17</a:t>
-            </a:r>
-            <a:br>
-              <a:rPr lang="en-US" dirty="0"/>
-            </a:br>
-            <a:br>
-              <a:rPr lang="en-US" dirty="0"/>
-            </a:br>
-            <a:r>
-              <a:rPr lang="en-US" dirty="0"/>
-              <a:t>Esempio Di notte non </a:t>
-            </a:r>
-            <a:r>
-              <a:rPr lang="en-US" dirty="0" err="1"/>
-              <a:t>c'è</a:t>
-            </a:r>
-            <a:r>
-              <a:rPr lang="en-US" dirty="0"/>
-              <a:t> il radar </a:t>
-            </a:r>
-            <a:r>
-              <a:rPr lang="en-US" dirty="0" err="1"/>
-              <a:t>nella</a:t>
-            </a:r>
-            <a:r>
-              <a:rPr lang="en-US" dirty="0"/>
-              <a:t> </a:t>
-            </a:r>
-            <a:r>
-              <a:rPr lang="en-US" dirty="0" err="1"/>
-              <a:t>stradina</a:t>
-            </a:r>
-            <a:r>
-              <a:rPr lang="en-US" dirty="0"/>
-              <a:t> di </a:t>
-            </a:r>
-            <a:r>
-              <a:rPr lang="en-US" dirty="0" err="1"/>
-              <a:t>paese</a:t>
-            </a:r>
-            <a:r>
-              <a:rPr lang="en-US" dirty="0"/>
-              <a:t> ma </a:t>
-            </a:r>
-            <a:r>
-              <a:rPr lang="en-US" dirty="0" err="1"/>
-              <a:t>nelle</a:t>
-            </a:r>
-            <a:r>
-              <a:rPr lang="en-US" dirty="0"/>
-              <a:t> </a:t>
-            </a:r>
-            <a:r>
-              <a:rPr lang="en-US" dirty="0" err="1"/>
-              <a:t>strade</a:t>
-            </a:r>
-            <a:r>
-              <a:rPr lang="en-US" dirty="0"/>
-              <a:t> </a:t>
-            </a:r>
-            <a:r>
-              <a:rPr lang="en-US" dirty="0" err="1"/>
-              <a:t>veloci</a:t>
-            </a:r>
-            <a:r>
-              <a:rPr lang="en-US" dirty="0"/>
-              <a:t>?</a:t>
-            </a:r>
-            <a:br>
-              <a:rPr lang="en-US" dirty="0"/>
-            </a:br>
-            <a:r>
-              <a:rPr lang="en-US" dirty="0"/>
-              <a:t>Vedi se </a:t>
-            </a:r>
-            <a:r>
-              <a:rPr lang="en-US" dirty="0" err="1"/>
-              <a:t>è</a:t>
-            </a:r>
-            <a:r>
-              <a:rPr lang="en-US" dirty="0"/>
-              <a:t> </a:t>
-            </a:r>
-            <a:r>
-              <a:rPr lang="en-US" dirty="0" err="1"/>
-              <a:t>vero</a:t>
-            </a:r>
-            <a:endParaRPr lang="en-US" dirty="0"/>
-          </a:p>
-        </p:txBody>
-      </p:sp>
-      <p:sp>
-        <p:nvSpPr>
-          <p:cNvPr id="4" name="Slide Number Placeholder 3"/>
-          <p:cNvSpPr>
-            <a:spLocks noGrp="1"/>
-          </p:cNvSpPr>
-          <p:nvPr>
-            <p:ph type="sldNum" sz="quarter" idx="10"/>
-          </p:nvPr>
-        </p:nvSpPr>
-        <p:spPr/>
-        <p:txBody>
-          <a:bodyPr/>
-          <a:lstStyle/>
-          <a:p>
-            <a:fld id="{F7021451-1387-4CA6-816F-3879F97B5CBC}" type="slidenum">
-              <a:rPr lang="en-US"/>
-              <a:t>9</a:t>
-            </a:fld>
-            <a:endParaRPr lang="en-US"/>
-          </a:p>
-        </p:txBody>
-      </p:sp>
-    </p:spTree>
-    <p:extLst>
-      <p:ext uri="{BB962C8B-B14F-4D97-AF65-F5344CB8AC3E}">
-        <p14:creationId xmlns:p14="http://schemas.microsoft.com/office/powerpoint/2010/main" val="1024086991"/>
       </p:ext>
     </p:extLst>
   </p:cSld>
@@ -3798,6 +4052,420 @@
 </file>
 
 <file path=ppt/slides/slide10.xml><?xml version="1.0" encoding="utf-8"?>
+<p:sld xmlns:a="http://schemas.openxmlformats.org/drawingml/2006/main" xmlns:r="http://schemas.openxmlformats.org/officeDocument/2006/relationships" xmlns:p="http://schemas.openxmlformats.org/presentationml/2006/main" show="0">
+  <p:cSld name="Slide 8">
+    <p:bg>
+      <p:bgPr>
+        <a:solidFill>
+          <a:srgbClr val="1A2744"/>
+        </a:solidFill>
+        <a:effectLst/>
+      </p:bgPr>
+    </p:bg>
+    <p:spTree>
+      <p:nvGrpSpPr>
+        <p:cNvPr id="1" name=""/>
+        <p:cNvGrpSpPr/>
+        <p:nvPr/>
+      </p:nvGrpSpPr>
+      <p:grpSpPr>
+        <a:xfrm>
+          <a:off x="0" y="0"/>
+          <a:ext cx="0" cy="0"/>
+          <a:chOff x="0" y="0"/>
+          <a:chExt cx="0" cy="0"/>
+        </a:xfrm>
+      </p:grpSpPr>
+      <p:sp>
+        <p:nvSpPr>
+          <p:cNvPr id="2" name="Shape 0"/>
+          <p:cNvSpPr/>
+          <p:nvPr/>
+        </p:nvSpPr>
+        <p:spPr>
+          <a:xfrm>
+            <a:off x="0" y="0"/>
+            <a:ext cx="164592" cy="5143500"/>
+          </a:xfrm>
+          <a:prstGeom prst="rect">
+            <a:avLst/>
+          </a:prstGeom>
+          <a:solidFill>
+            <a:srgbClr val="00B4D8"/>
+          </a:solidFill>
+          <a:ln w="12700">
+            <a:solidFill>
+              <a:srgbClr val="00B4D8"/>
+            </a:solidFill>
+            <a:prstDash val="solid"/>
+          </a:ln>
+        </p:spPr>
+        <p:txBody>
+          <a:bodyPr/>
+          <a:lstStyle/>
+          <a:p>
+            <a:endParaRPr lang="it-CH"/>
+          </a:p>
+        </p:txBody>
+      </p:sp>
+      <p:sp>
+        <p:nvSpPr>
+          <p:cNvPr id="3" name="Text 1"/>
+          <p:cNvSpPr/>
+          <p:nvPr/>
+        </p:nvSpPr>
+        <p:spPr>
+          <a:xfrm>
+            <a:off x="365760" y="164592"/>
+            <a:ext cx="8412480" cy="548640"/>
+          </a:xfrm>
+          <a:prstGeom prst="rect">
+            <a:avLst/>
+          </a:prstGeom>
+          <a:noFill/>
+          <a:ln/>
+        </p:spPr>
+        <p:txBody>
+          <a:bodyPr wrap="square" lIns="0" tIns="0" rIns="0" bIns="0" rtlCol="0" anchor="ctr"/>
+          <a:lstStyle/>
+          <a:p>
+            <a:pPr marL="0" indent="0">
+              <a:buNone/>
+            </a:pPr>
+            <a:r>
+              <a:rPr lang="en-US" sz="2200" b="1" dirty="0">
+                <a:solidFill>
+                  <a:srgbClr val="00B4D8"/>
+                </a:solidFill>
+                <a:latin typeface="Calibri" pitchFamily="34" charset="0"/>
+                <a:ea typeface="Calibri" pitchFamily="34" charset="-122"/>
+                <a:cs typeface="Calibri" pitchFamily="34" charset="-120"/>
+              </a:rPr>
+              <a:t>Analisi Future Pianificate</a:t>
+            </a:r>
+            <a:endParaRPr lang="en-US" sz="2200" dirty="0"/>
+          </a:p>
+        </p:txBody>
+      </p:sp>
+      <p:sp>
+        <p:nvSpPr>
+          <p:cNvPr id="5" name="Shape 3"/>
+          <p:cNvSpPr/>
+          <p:nvPr/>
+        </p:nvSpPr>
+        <p:spPr>
+          <a:xfrm>
+            <a:off x="365760" y="838830"/>
+            <a:ext cx="8503920" cy="4007490"/>
+          </a:xfrm>
+          <a:prstGeom prst="rect">
+            <a:avLst/>
+          </a:prstGeom>
+          <a:solidFill>
+            <a:srgbClr val="1E3057"/>
+          </a:solidFill>
+          <a:ln w="12700">
+            <a:solidFill>
+              <a:srgbClr val="2A4580"/>
+            </a:solidFill>
+            <a:prstDash val="solid"/>
+          </a:ln>
+        </p:spPr>
+        <p:txBody>
+          <a:bodyPr/>
+          <a:lstStyle/>
+          <a:p>
+            <a:endParaRPr lang="it-CH"/>
+          </a:p>
+        </p:txBody>
+      </p:sp>
+      <p:sp>
+        <p:nvSpPr>
+          <p:cNvPr id="6" name="Text 4"/>
+          <p:cNvSpPr/>
+          <p:nvPr/>
+        </p:nvSpPr>
+        <p:spPr>
+          <a:xfrm>
+            <a:off x="365760" y="1234440"/>
+            <a:ext cx="8503920" cy="3611880"/>
+          </a:xfrm>
+          <a:prstGeom prst="rect">
+            <a:avLst/>
+          </a:prstGeom>
+          <a:noFill/>
+          <a:ln/>
+        </p:spPr>
+        <p:txBody>
+          <a:bodyPr wrap="square" lIns="0" tIns="0" rIns="0" bIns="0" rtlCol="0" anchor="ctr"/>
+          <a:lstStyle/>
+          <a:p>
+            <a:pPr marL="0" indent="0" algn="ctr">
+              <a:buNone/>
+            </a:pPr>
+            <a:endParaRPr lang="en-US" sz="1400" dirty="0"/>
+          </a:p>
+        </p:txBody>
+      </p:sp>
+      <p:sp>
+        <p:nvSpPr>
+          <p:cNvPr id="4" name="Text 2"/>
+          <p:cNvSpPr/>
+          <p:nvPr/>
+        </p:nvSpPr>
+        <p:spPr>
+          <a:xfrm>
+            <a:off x="687688" y="958740"/>
+            <a:ext cx="8181991" cy="3673715"/>
+          </a:xfrm>
+          <a:prstGeom prst="rect">
+            <a:avLst/>
+          </a:prstGeom>
+          <a:noFill/>
+          <a:ln/>
+        </p:spPr>
+        <p:txBody>
+          <a:bodyPr wrap="square" lIns="0" tIns="0" rIns="0" bIns="0" rtlCol="0" anchor="ctr"/>
+          <a:lstStyle/>
+          <a:p>
+            <a:pPr marL="342900" indent="-342900">
+              <a:buFont typeface="+mj-lt"/>
+              <a:buAutoNum type="arabicPeriod"/>
+            </a:pPr>
+            <a:r>
+              <a:rPr lang="en-US" sz="2400" i="1" dirty="0" err="1">
+                <a:solidFill>
+                  <a:srgbClr val="B0BEC5"/>
+                </a:solidFill>
+                <a:latin typeface="Calibri" pitchFamily="34" charset="0"/>
+                <a:ea typeface="Calibri" pitchFamily="34" charset="-122"/>
+                <a:cs typeface="Calibri" pitchFamily="34" charset="-120"/>
+              </a:rPr>
+              <a:t>Correlazione</a:t>
+            </a:r>
+            <a:r>
+              <a:rPr lang="en-US" sz="2400" i="1" dirty="0">
+                <a:solidFill>
+                  <a:srgbClr val="B0BEC5"/>
+                </a:solidFill>
+                <a:latin typeface="Calibri" pitchFamily="34" charset="0"/>
+                <a:ea typeface="Calibri" pitchFamily="34" charset="-122"/>
+                <a:cs typeface="Calibri" pitchFamily="34" charset="-120"/>
+              </a:rPr>
+              <a:t> </a:t>
+            </a:r>
+            <a:r>
+              <a:rPr lang="en-US" sz="2400" i="1" dirty="0" err="1">
+                <a:solidFill>
+                  <a:srgbClr val="B0BEC5"/>
+                </a:solidFill>
+                <a:latin typeface="Calibri" pitchFamily="34" charset="0"/>
+                <a:ea typeface="Calibri" pitchFamily="34" charset="-122"/>
+                <a:cs typeface="Calibri" pitchFamily="34" charset="-120"/>
+              </a:rPr>
+              <a:t>meteo</a:t>
+            </a:r>
+            <a:r>
+              <a:rPr lang="en-US" sz="2400" i="1" dirty="0">
+                <a:solidFill>
+                  <a:srgbClr val="B0BEC5"/>
+                </a:solidFill>
+                <a:latin typeface="Calibri" pitchFamily="34" charset="0"/>
+                <a:ea typeface="Calibri" pitchFamily="34" charset="-122"/>
+                <a:cs typeface="Calibri" pitchFamily="34" charset="-120"/>
+              </a:rPr>
+              <a:t> </a:t>
+            </a:r>
+          </a:p>
+          <a:p>
+            <a:pPr marL="342900" indent="-342900">
+              <a:buFont typeface="+mj-lt"/>
+              <a:buAutoNum type="arabicPeriod"/>
+            </a:pPr>
+            <a:r>
+              <a:rPr lang="en-US" sz="2400" i="1" dirty="0" err="1">
+                <a:solidFill>
+                  <a:srgbClr val="B0BEC5"/>
+                </a:solidFill>
+                <a:latin typeface="Calibri" pitchFamily="34" charset="0"/>
+                <a:ea typeface="Calibri" pitchFamily="34" charset="-122"/>
+                <a:cs typeface="Calibri" pitchFamily="34" charset="-120"/>
+              </a:rPr>
+              <a:t>Differenza</a:t>
+            </a:r>
+            <a:r>
+              <a:rPr lang="en-US" sz="2400" i="1" dirty="0">
+                <a:solidFill>
+                  <a:srgbClr val="B0BEC5"/>
+                </a:solidFill>
+                <a:latin typeface="Calibri" pitchFamily="34" charset="0"/>
+                <a:ea typeface="Calibri" pitchFamily="34" charset="-122"/>
+                <a:cs typeface="Calibri" pitchFamily="34" charset="-120"/>
+              </a:rPr>
+              <a:t> </a:t>
+            </a:r>
+            <a:r>
+              <a:rPr lang="en-US" sz="2400" i="1" dirty="0" err="1">
+                <a:solidFill>
+                  <a:srgbClr val="B0BEC5"/>
+                </a:solidFill>
+                <a:latin typeface="Calibri" pitchFamily="34" charset="0"/>
+                <a:ea typeface="Calibri" pitchFamily="34" charset="-122"/>
+                <a:cs typeface="Calibri" pitchFamily="34" charset="-120"/>
+              </a:rPr>
+              <a:t>velocità</a:t>
+            </a:r>
+            <a:r>
+              <a:rPr lang="en-US" sz="2400" i="1" dirty="0">
+                <a:solidFill>
+                  <a:srgbClr val="B0BEC5"/>
+                </a:solidFill>
+                <a:latin typeface="Calibri" pitchFamily="34" charset="0"/>
+                <a:ea typeface="Calibri" pitchFamily="34" charset="-122"/>
+                <a:cs typeface="Calibri" pitchFamily="34" charset="-120"/>
+              </a:rPr>
+              <a:t> – </a:t>
+            </a:r>
+            <a:r>
+              <a:rPr lang="en-US" sz="2400" i="1" dirty="0" err="1">
+                <a:solidFill>
+                  <a:srgbClr val="B0BEC5"/>
+                </a:solidFill>
+                <a:latin typeface="Calibri" pitchFamily="34" charset="0"/>
+                <a:ea typeface="Calibri" pitchFamily="34" charset="-122"/>
+                <a:cs typeface="Calibri" pitchFamily="34" charset="-120"/>
+              </a:rPr>
+              <a:t>tipo</a:t>
+            </a:r>
+            <a:r>
+              <a:rPr lang="en-US" sz="2400" i="1" dirty="0">
+                <a:solidFill>
+                  <a:srgbClr val="B0BEC5"/>
+                </a:solidFill>
+                <a:latin typeface="Calibri" pitchFamily="34" charset="0"/>
+                <a:ea typeface="Calibri" pitchFamily="34" charset="-122"/>
+                <a:cs typeface="Calibri" pitchFamily="34" charset="-120"/>
+              </a:rPr>
+              <a:t> di </a:t>
+            </a:r>
+            <a:r>
+              <a:rPr lang="en-US" sz="2400" i="1" dirty="0" err="1">
+                <a:solidFill>
+                  <a:srgbClr val="B0BEC5"/>
+                </a:solidFill>
+                <a:latin typeface="Calibri" pitchFamily="34" charset="0"/>
+                <a:ea typeface="Calibri" pitchFamily="34" charset="-122"/>
+                <a:cs typeface="Calibri" pitchFamily="34" charset="-120"/>
+              </a:rPr>
+              <a:t>veicolo</a:t>
+            </a:r>
+            <a:r>
+              <a:rPr lang="en-US" sz="2400" i="1" dirty="0">
+                <a:solidFill>
+                  <a:srgbClr val="B0BEC5"/>
+                </a:solidFill>
+                <a:latin typeface="Calibri" pitchFamily="34" charset="0"/>
+                <a:ea typeface="Calibri" pitchFamily="34" charset="-122"/>
+                <a:cs typeface="Calibri" pitchFamily="34" charset="-120"/>
+              </a:rPr>
+              <a:t> (moto/camion)</a:t>
+            </a:r>
+          </a:p>
+          <a:p>
+            <a:pPr marL="342900" indent="-342900">
+              <a:buFont typeface="+mj-lt"/>
+              <a:buAutoNum type="arabicPeriod"/>
+            </a:pPr>
+            <a:r>
+              <a:rPr lang="en-US" sz="2400" i="1" dirty="0" err="1">
+                <a:solidFill>
+                  <a:srgbClr val="B0BEC5"/>
+                </a:solidFill>
+                <a:latin typeface="Calibri" pitchFamily="34" charset="0"/>
+                <a:ea typeface="Calibri" pitchFamily="34" charset="-122"/>
+                <a:cs typeface="Calibri" pitchFamily="34" charset="-120"/>
+              </a:rPr>
+              <a:t>Differenza</a:t>
+            </a:r>
+            <a:r>
+              <a:rPr lang="en-US" sz="2400" i="1" dirty="0">
+                <a:solidFill>
+                  <a:srgbClr val="B0BEC5"/>
+                </a:solidFill>
+                <a:latin typeface="Calibri" pitchFamily="34" charset="0"/>
+                <a:ea typeface="Calibri" pitchFamily="34" charset="-122"/>
+                <a:cs typeface="Calibri" pitchFamily="34" charset="-120"/>
+              </a:rPr>
+              <a:t> </a:t>
+            </a:r>
+            <a:r>
+              <a:rPr lang="en-US" sz="2400" i="1" dirty="0" err="1">
+                <a:solidFill>
+                  <a:srgbClr val="B0BEC5"/>
+                </a:solidFill>
+                <a:latin typeface="Calibri" pitchFamily="34" charset="0"/>
+                <a:ea typeface="Calibri" pitchFamily="34" charset="-122"/>
+                <a:cs typeface="Calibri" pitchFamily="34" charset="-120"/>
+              </a:rPr>
+              <a:t>postazioni</a:t>
+            </a:r>
+            <a:r>
+              <a:rPr lang="en-US" sz="2400" i="1" dirty="0">
+                <a:solidFill>
+                  <a:srgbClr val="B0BEC5"/>
+                </a:solidFill>
+                <a:latin typeface="Calibri" pitchFamily="34" charset="0"/>
+                <a:ea typeface="Calibri" pitchFamily="34" charset="-122"/>
+                <a:cs typeface="Calibri" pitchFamily="34" charset="-120"/>
+              </a:rPr>
+              <a:t> radar Giorno-notte</a:t>
+            </a:r>
+          </a:p>
+          <a:p>
+            <a:pPr marL="342900" indent="-342900">
+              <a:buFont typeface="+mj-lt"/>
+              <a:buAutoNum type="arabicPeriod"/>
+            </a:pPr>
+            <a:r>
+              <a:rPr lang="en-US" sz="2400" i="1" dirty="0">
+                <a:solidFill>
+                  <a:srgbClr val="B0BEC5"/>
+                </a:solidFill>
+                <a:latin typeface="Calibri" pitchFamily="34" charset="0"/>
+                <a:ea typeface="Calibri" pitchFamily="34" charset="-122"/>
+                <a:cs typeface="Calibri" pitchFamily="34" charset="-120"/>
+              </a:rPr>
+              <a:t>…</a:t>
+            </a:r>
+          </a:p>
+          <a:p>
+            <a:pPr marL="342900" indent="-342900">
+              <a:buFont typeface="+mj-lt"/>
+              <a:buAutoNum type="arabicPeriod"/>
+            </a:pPr>
+            <a:r>
+              <a:rPr lang="en-US" sz="2400" i="1" dirty="0">
+                <a:solidFill>
+                  <a:srgbClr val="B0BEC5"/>
+                </a:solidFill>
+                <a:latin typeface="Calibri" pitchFamily="34" charset="0"/>
+                <a:ea typeface="Calibri" pitchFamily="34" charset="-122"/>
+                <a:cs typeface="Calibri" pitchFamily="34" charset="-120"/>
+              </a:rPr>
+              <a:t>Consigli?</a:t>
+            </a:r>
+          </a:p>
+        </p:txBody>
+      </p:sp>
+    </p:spTree>
+  </p:cSld>
+  <p:clrMapOvr>
+    <a:masterClrMapping/>
+  </p:clrMapOvr>
+</p:sld>
+</file>
+
+<file path=ppt/slides/slide11.xml><?xml version="1.0" encoding="utf-8"?>
 <p:sld xmlns:a="http://schemas.openxmlformats.org/drawingml/2006/main" xmlns:r="http://schemas.openxmlformats.org/officeDocument/2006/relationships" xmlns:p="http://schemas.openxmlformats.org/presentationml/2006/main">
   <p:cSld name="Slide 9">
     <p:bg>
@@ -6279,6 +6947,17 @@
               <a:buNone/>
             </a:pPr>
             <a:r>
+              <a:rPr lang="en-US" sz="2200" b="1" dirty="0" err="1">
+                <a:solidFill>
+                  <a:srgbClr val="00B4D8"/>
+                </a:solidFill>
+                <a:latin typeface="Calibri" pitchFamily="34" charset="0"/>
+                <a:ea typeface="Calibri" pitchFamily="34" charset="-122"/>
+                <a:cs typeface="Calibri" pitchFamily="34" charset="-120"/>
+              </a:rPr>
+              <a:t>Misurazione</a:t>
+            </a:r>
+            <a:r>
               <a:rPr lang="en-US" sz="2200" b="1" dirty="0">
                 <a:solidFill>
                   <a:srgbClr val="00B4D8"/>
@@ -6287,7 +6966,7 @@
                 <a:ea typeface="Calibri" pitchFamily="34" charset="-122"/>
                 <a:cs typeface="Calibri" pitchFamily="34" charset="-120"/>
               </a:rPr>
-              <a:t>Mappa di Calore – </a:t>
+              <a:t> </a:t>
             </a:r>
             <a:r>
               <a:rPr lang="en-US" sz="2200" b="1" dirty="0" err="1">
@@ -6298,7 +6977,7 @@
                 <a:ea typeface="Calibri" pitchFamily="34" charset="-122"/>
                 <a:cs typeface="Calibri" pitchFamily="34" charset="-120"/>
               </a:rPr>
-              <a:t>Velocità</a:t>
+              <a:t>veicoli</a:t>
             </a:r>
             <a:r>
               <a:rPr lang="en-US" sz="2200" b="1" dirty="0">
@@ -6309,7 +6988,7 @@
                 <a:ea typeface="Calibri" pitchFamily="34" charset="-122"/>
                 <a:cs typeface="Calibri" pitchFamily="34" charset="-120"/>
               </a:rPr>
-              <a:t> media per </a:t>
+              <a:t> / </a:t>
             </a:r>
             <a:r>
               <a:rPr lang="en-US" sz="2200" b="1" dirty="0" err="1">
@@ -6320,7 +6999,7 @@
                 <a:ea typeface="Calibri" pitchFamily="34" charset="-122"/>
                 <a:cs typeface="Calibri" pitchFamily="34" charset="-120"/>
               </a:rPr>
-              <a:t>orario</a:t>
+              <a:t>giorno</a:t>
             </a:r>
             <a:endParaRPr lang="en-US" sz="2200" dirty="0"/>
           </a:p>
@@ -6359,7 +7038,29 @@
                 <a:ea typeface="Calibri" pitchFamily="34" charset="-122"/>
                 <a:cs typeface="Calibri" pitchFamily="34" charset="-120"/>
               </a:rPr>
-              <a:t>Heatmap – velocita_kmh media per </a:t>
+              <a:t>Heatmap – media </a:t>
+            </a:r>
+            <a:r>
+              <a:rPr lang="en-US" sz="1300" i="1" dirty="0" err="1">
+                <a:solidFill>
+                  <a:srgbClr val="B0BEC5"/>
+                </a:solidFill>
+                <a:latin typeface="Calibri" pitchFamily="34" charset="0"/>
+                <a:ea typeface="Calibri" pitchFamily="34" charset="-122"/>
+                <a:cs typeface="Calibri" pitchFamily="34" charset="-120"/>
+              </a:rPr>
+              <a:t>misurazioni</a:t>
+            </a:r>
+            <a:r>
+              <a:rPr lang="en-US" sz="1300" i="1" dirty="0">
+                <a:solidFill>
+                  <a:srgbClr val="B0BEC5"/>
+                </a:solidFill>
+                <a:latin typeface="Calibri" pitchFamily="34" charset="0"/>
+                <a:ea typeface="Calibri" pitchFamily="34" charset="-122"/>
+                <a:cs typeface="Calibri" pitchFamily="34" charset="-120"/>
+              </a:rPr>
+              <a:t> per </a:t>
             </a:r>
             <a:r>
               <a:rPr lang="en-US" sz="1300" i="1" dirty="0" err="1">
@@ -6460,10 +7161,10 @@
       </p:sp>
       <p:pic>
         <p:nvPicPr>
-          <p:cNvPr id="12" name="Immagine 11">
+          <p:cNvPr id="13" name="Immagine 12">
             <a:extLst>
               <a:ext uri="{FF2B5EF4-FFF2-40B4-BE49-F238E27FC236}">
-                <a16:creationId xmlns:a16="http://schemas.microsoft.com/office/drawing/2014/main" id="{8F8FBDB0-6A36-CB34-BBFE-D20411E9CAD9}"/>
+                <a16:creationId xmlns:a16="http://schemas.microsoft.com/office/drawing/2014/main" id="{24C6FEB0-4051-3D7A-1A2A-AA3F6AA273CB}"/>
               </a:ext>
             </a:extLst>
           </p:cNvPr>
@@ -6480,8 +7181,8 @@
         </p:blipFill>
         <p:spPr>
           <a:xfrm>
-            <a:off x="365759" y="1234440"/>
-            <a:ext cx="8494607" cy="3611880"/>
+            <a:off x="365760" y="1234440"/>
+            <a:ext cx="8507986" cy="3611880"/>
           </a:xfrm>
           <a:prstGeom prst="rect">
             <a:avLst/>
@@ -6896,6 +7597,379 @@
         <p:cNvPr id="1" name="">
           <a:extLst>
             <a:ext uri="{FF2B5EF4-FFF2-40B4-BE49-F238E27FC236}">
+              <a16:creationId xmlns:a16="http://schemas.microsoft.com/office/drawing/2014/main" id="{050129B8-E4DE-6B76-0BC9-A2432BB417CA}"/>
+            </a:ext>
+          </a:extLst>
+        </p:cNvPr>
+        <p:cNvGrpSpPr/>
+        <p:nvPr/>
+      </p:nvGrpSpPr>
+      <p:grpSpPr>
+        <a:xfrm>
+          <a:off x="0" y="0"/>
+          <a:ext cx="0" cy="0"/>
+          <a:chOff x="0" y="0"/>
+          <a:chExt cx="0" cy="0"/>
+        </a:xfrm>
+      </p:grpSpPr>
+      <p:sp>
+        <p:nvSpPr>
+          <p:cNvPr id="2" name="Shape 0">
+            <a:extLst>
+              <a:ext uri="{FF2B5EF4-FFF2-40B4-BE49-F238E27FC236}">
+                <a16:creationId xmlns:a16="http://schemas.microsoft.com/office/drawing/2014/main" id="{EEE77AE3-2F8A-0CC3-E76B-C9D29CE0A3BC}"/>
+              </a:ext>
+            </a:extLst>
+          </p:cNvPr>
+          <p:cNvSpPr/>
+          <p:nvPr/>
+        </p:nvSpPr>
+        <p:spPr>
+          <a:xfrm>
+            <a:off x="0" y="0"/>
+            <a:ext cx="164592" cy="5143500"/>
+          </a:xfrm>
+          <a:prstGeom prst="rect">
+            <a:avLst/>
+          </a:prstGeom>
+          <a:solidFill>
+            <a:srgbClr val="00B4D8"/>
+          </a:solidFill>
+          <a:ln w="12700">
+            <a:solidFill>
+              <a:srgbClr val="00B4D8"/>
+            </a:solidFill>
+            <a:prstDash val="solid"/>
+          </a:ln>
+        </p:spPr>
+        <p:txBody>
+          <a:bodyPr/>
+          <a:lstStyle/>
+          <a:p>
+            <a:endParaRPr lang="it-CH"/>
+          </a:p>
+        </p:txBody>
+      </p:sp>
+      <p:sp>
+        <p:nvSpPr>
+          <p:cNvPr id="3" name="Text 1">
+            <a:extLst>
+              <a:ext uri="{FF2B5EF4-FFF2-40B4-BE49-F238E27FC236}">
+                <a16:creationId xmlns:a16="http://schemas.microsoft.com/office/drawing/2014/main" id="{5B52C3B0-B814-C8CA-B170-63256395B692}"/>
+              </a:ext>
+            </a:extLst>
+          </p:cNvPr>
+          <p:cNvSpPr/>
+          <p:nvPr/>
+        </p:nvSpPr>
+        <p:spPr>
+          <a:xfrm>
+            <a:off x="365760" y="164592"/>
+            <a:ext cx="8412480" cy="548640"/>
+          </a:xfrm>
+          <a:prstGeom prst="rect">
+            <a:avLst/>
+          </a:prstGeom>
+          <a:noFill/>
+          <a:ln/>
+        </p:spPr>
+        <p:txBody>
+          <a:bodyPr wrap="square" lIns="0" tIns="0" rIns="0" bIns="0" rtlCol="0" anchor="ctr"/>
+          <a:lstStyle/>
+          <a:p>
+            <a:pPr marL="0" indent="0">
+              <a:buNone/>
+            </a:pPr>
+            <a:r>
+              <a:rPr lang="en-US" sz="2200" b="1" dirty="0" err="1">
+                <a:solidFill>
+                  <a:srgbClr val="00B4D8"/>
+                </a:solidFill>
+                <a:latin typeface="Calibri" pitchFamily="34" charset="0"/>
+                <a:ea typeface="Calibri" pitchFamily="34" charset="-122"/>
+                <a:cs typeface="Calibri" pitchFamily="34" charset="-120"/>
+              </a:rPr>
+              <a:t>Infrazioni</a:t>
+            </a:r>
+            <a:r>
+              <a:rPr lang="en-US" sz="2200" b="1" dirty="0">
+                <a:solidFill>
+                  <a:srgbClr val="00B4D8"/>
+                </a:solidFill>
+                <a:latin typeface="Calibri" pitchFamily="34" charset="0"/>
+                <a:ea typeface="Calibri" pitchFamily="34" charset="-122"/>
+                <a:cs typeface="Calibri" pitchFamily="34" charset="-120"/>
+              </a:rPr>
+              <a:t>/Anno con </a:t>
+            </a:r>
+            <a:r>
+              <a:rPr lang="en-US" sz="2200" b="1" dirty="0" err="1">
+                <a:solidFill>
+                  <a:srgbClr val="00B4D8"/>
+                </a:solidFill>
+                <a:latin typeface="Calibri" pitchFamily="34" charset="0"/>
+                <a:ea typeface="Calibri" pitchFamily="34" charset="-122"/>
+                <a:cs typeface="Calibri" pitchFamily="34" charset="-120"/>
+              </a:rPr>
+              <a:t>categoria</a:t>
+            </a:r>
+            <a:r>
+              <a:rPr lang="en-US" sz="2200" b="1" dirty="0">
+                <a:solidFill>
+                  <a:srgbClr val="00B4D8"/>
+                </a:solidFill>
+                <a:latin typeface="Calibri" pitchFamily="34" charset="0"/>
+                <a:ea typeface="Calibri" pitchFamily="34" charset="-122"/>
+                <a:cs typeface="Calibri" pitchFamily="34" charset="-120"/>
+              </a:rPr>
+              <a:t> </a:t>
+            </a:r>
+            <a:r>
+              <a:rPr lang="en-US" sz="2200" b="1" dirty="0" err="1">
+                <a:solidFill>
+                  <a:srgbClr val="00B4D8"/>
+                </a:solidFill>
+                <a:latin typeface="Calibri" pitchFamily="34" charset="0"/>
+                <a:ea typeface="Calibri" pitchFamily="34" charset="-122"/>
+                <a:cs typeface="Calibri" pitchFamily="34" charset="-120"/>
+              </a:rPr>
+              <a:t>veicolo</a:t>
+            </a:r>
+            <a:endParaRPr lang="en-US" sz="2200" dirty="0"/>
+          </a:p>
+        </p:txBody>
+      </p:sp>
+      <p:sp>
+        <p:nvSpPr>
+          <p:cNvPr id="4" name="Text 2">
+            <a:extLst>
+              <a:ext uri="{FF2B5EF4-FFF2-40B4-BE49-F238E27FC236}">
+                <a16:creationId xmlns:a16="http://schemas.microsoft.com/office/drawing/2014/main" id="{4C4DBECF-076C-8656-D72F-77C3B08900DA}"/>
+              </a:ext>
+            </a:extLst>
+          </p:cNvPr>
+          <p:cNvSpPr/>
+          <p:nvPr/>
+        </p:nvSpPr>
+        <p:spPr>
+          <a:xfrm>
+            <a:off x="365760" y="804672"/>
+            <a:ext cx="8412480" cy="320040"/>
+          </a:xfrm>
+          <a:prstGeom prst="rect">
+            <a:avLst/>
+          </a:prstGeom>
+          <a:noFill/>
+          <a:ln/>
+        </p:spPr>
+        <p:txBody>
+          <a:bodyPr wrap="square" lIns="0" tIns="0" rIns="0" bIns="0" rtlCol="0" anchor="ctr"/>
+          <a:lstStyle/>
+          <a:p>
+            <a:pPr marL="0" indent="0">
+              <a:buNone/>
+            </a:pPr>
+            <a:r>
+              <a:rPr lang="en-US" sz="1300" i="1" dirty="0" err="1">
+                <a:solidFill>
+                  <a:srgbClr val="B0BEC5"/>
+                </a:solidFill>
+                <a:latin typeface="Calibri" pitchFamily="34" charset="0"/>
+                <a:ea typeface="Calibri" pitchFamily="34" charset="-122"/>
+                <a:cs typeface="Calibri" pitchFamily="34" charset="-120"/>
+              </a:rPr>
+              <a:t>SubPlot</a:t>
+            </a:r>
+            <a:r>
+              <a:rPr lang="en-US" sz="1300" i="1" dirty="0">
+                <a:solidFill>
+                  <a:srgbClr val="B0BEC5"/>
+                </a:solidFill>
+                <a:latin typeface="Calibri" pitchFamily="34" charset="0"/>
+                <a:ea typeface="Calibri" pitchFamily="34" charset="-122"/>
+                <a:cs typeface="Calibri" pitchFamily="34" charset="-120"/>
+              </a:rPr>
+              <a:t> – media annua </a:t>
+            </a:r>
+            <a:r>
+              <a:rPr lang="en-US" sz="1300" i="1" dirty="0" err="1">
+                <a:solidFill>
+                  <a:srgbClr val="B0BEC5"/>
+                </a:solidFill>
+                <a:latin typeface="Calibri" pitchFamily="34" charset="0"/>
+                <a:ea typeface="Calibri" pitchFamily="34" charset="-122"/>
+                <a:cs typeface="Calibri" pitchFamily="34" charset="-120"/>
+              </a:rPr>
+              <a:t>infrazioni</a:t>
+            </a:r>
+            <a:r>
+              <a:rPr lang="en-US" sz="1300" i="1" dirty="0">
+                <a:solidFill>
+                  <a:srgbClr val="B0BEC5"/>
+                </a:solidFill>
+                <a:latin typeface="Calibri" pitchFamily="34" charset="0"/>
+                <a:ea typeface="Calibri" pitchFamily="34" charset="-122"/>
+                <a:cs typeface="Calibri" pitchFamily="34" charset="-120"/>
+              </a:rPr>
+              <a:t> </a:t>
+            </a:r>
+            <a:r>
+              <a:rPr lang="en-US" sz="1300" i="1" dirty="0" err="1">
+                <a:solidFill>
+                  <a:srgbClr val="B0BEC5"/>
+                </a:solidFill>
+                <a:latin typeface="Calibri" pitchFamily="34" charset="0"/>
+                <a:ea typeface="Calibri" pitchFamily="34" charset="-122"/>
+                <a:cs typeface="Calibri" pitchFamily="34" charset="-120"/>
+              </a:rPr>
+              <a:t>veicoli</a:t>
+            </a:r>
+            <a:endParaRPr lang="en-US" sz="1300" dirty="0"/>
+          </a:p>
+        </p:txBody>
+      </p:sp>
+      <p:sp>
+        <p:nvSpPr>
+          <p:cNvPr id="5" name="Shape 3">
+            <a:extLst>
+              <a:ext uri="{FF2B5EF4-FFF2-40B4-BE49-F238E27FC236}">
+                <a16:creationId xmlns:a16="http://schemas.microsoft.com/office/drawing/2014/main" id="{CB0BA3C2-F945-E20F-0EED-21B8FA22FDB2}"/>
+              </a:ext>
+            </a:extLst>
+          </p:cNvPr>
+          <p:cNvSpPr/>
+          <p:nvPr/>
+        </p:nvSpPr>
+        <p:spPr>
+          <a:xfrm>
+            <a:off x="365760" y="1234440"/>
+            <a:ext cx="8503920" cy="3611880"/>
+          </a:xfrm>
+          <a:prstGeom prst="rect">
+            <a:avLst/>
+          </a:prstGeom>
+          <a:solidFill>
+            <a:srgbClr val="1E3057"/>
+          </a:solidFill>
+          <a:ln w="12700">
+            <a:solidFill>
+              <a:srgbClr val="2A4580"/>
+            </a:solidFill>
+            <a:prstDash val="solid"/>
+          </a:ln>
+        </p:spPr>
+        <p:txBody>
+          <a:bodyPr/>
+          <a:lstStyle/>
+          <a:p>
+            <a:endParaRPr lang="it-CH"/>
+          </a:p>
+        </p:txBody>
+      </p:sp>
+      <p:sp>
+        <p:nvSpPr>
+          <p:cNvPr id="6" name="Text 4">
+            <a:extLst>
+              <a:ext uri="{FF2B5EF4-FFF2-40B4-BE49-F238E27FC236}">
+                <a16:creationId xmlns:a16="http://schemas.microsoft.com/office/drawing/2014/main" id="{0B822438-0145-720B-1E64-8C38E17D03DC}"/>
+              </a:ext>
+            </a:extLst>
+          </p:cNvPr>
+          <p:cNvSpPr/>
+          <p:nvPr/>
+        </p:nvSpPr>
+        <p:spPr>
+          <a:xfrm>
+            <a:off x="365760" y="1234440"/>
+            <a:ext cx="8503920" cy="3611880"/>
+          </a:xfrm>
+          <a:prstGeom prst="rect">
+            <a:avLst/>
+          </a:prstGeom>
+          <a:noFill/>
+          <a:ln/>
+        </p:spPr>
+        <p:txBody>
+          <a:bodyPr wrap="square" lIns="0" tIns="0" rIns="0" bIns="0" rtlCol="0" anchor="ctr"/>
+          <a:lstStyle/>
+          <a:p>
+            <a:pPr marL="0" indent="0" algn="ctr">
+              <a:buNone/>
+            </a:pPr>
+            <a:r>
+              <a:rPr lang="en-US" sz="1400" dirty="0">
+                <a:solidFill>
+                  <a:srgbClr val="2A4580"/>
+                </a:solidFill>
+                <a:latin typeface="Calibri" pitchFamily="34" charset="0"/>
+                <a:ea typeface="Calibri" pitchFamily="34" charset="-122"/>
+                <a:cs typeface="Calibri" pitchFamily="34" charset="-120"/>
+              </a:rPr>
+              <a:t>[ grafico ]</a:t>
+            </a:r>
+            <a:endParaRPr lang="en-US" sz="1400" dirty="0"/>
+          </a:p>
+        </p:txBody>
+      </p:sp>
+      <p:pic>
+        <p:nvPicPr>
+          <p:cNvPr id="19" name="Immagine 18">
+            <a:extLst>
+              <a:ext uri="{FF2B5EF4-FFF2-40B4-BE49-F238E27FC236}">
+                <a16:creationId xmlns:a16="http://schemas.microsoft.com/office/drawing/2014/main" id="{6F9F199B-2953-EA32-C63D-DDFB19C0D98C}"/>
+              </a:ext>
+            </a:extLst>
+          </p:cNvPr>
+          <p:cNvPicPr>
+            <a:picLocks noChangeAspect="1"/>
+          </p:cNvPicPr>
+          <p:nvPr/>
+        </p:nvPicPr>
+        <p:blipFill>
+          <a:blip r:embed="rId3"/>
+          <a:stretch>
+            <a:fillRect/>
+          </a:stretch>
+        </p:blipFill>
+        <p:spPr>
+          <a:xfrm>
+            <a:off x="365760" y="1234440"/>
+            <a:ext cx="8503920" cy="3635095"/>
+          </a:xfrm>
+          <a:prstGeom prst="rect">
+            <a:avLst/>
+          </a:prstGeom>
+        </p:spPr>
+      </p:pic>
+    </p:spTree>
+    <p:extLst>
+      <p:ext uri="{BB962C8B-B14F-4D97-AF65-F5344CB8AC3E}">
+        <p14:creationId xmlns:p14="http://schemas.microsoft.com/office/powerpoint/2010/main" val="3364992709"/>
+      </p:ext>
+    </p:extLst>
+  </p:cSld>
+  <p:clrMapOvr>
+    <a:masterClrMapping/>
+  </p:clrMapOvr>
+</p:sld>
+</file>
+
+<file path=ppt/slides/slide8.xml><?xml version="1.0" encoding="utf-8"?>
+<p:sld xmlns:a="http://schemas.openxmlformats.org/drawingml/2006/main" xmlns:r="http://schemas.openxmlformats.org/officeDocument/2006/relationships" xmlns:p="http://schemas.openxmlformats.org/presentationml/2006/main">
+  <p:cSld>
+    <p:bg>
+      <p:bgPr>
+        <a:solidFill>
+          <a:srgbClr val="1A2744"/>
+        </a:solidFill>
+        <a:effectLst/>
+      </p:bgPr>
+    </p:bg>
+    <p:spTree>
+      <p:nvGrpSpPr>
+        <p:cNvPr id="1" name="">
+          <a:extLst>
+            <a:ext uri="{FF2B5EF4-FFF2-40B4-BE49-F238E27FC236}">
               <a16:creationId xmlns:a16="http://schemas.microsoft.com/office/drawing/2014/main" id="{B4AD0811-9B76-6461-72D6-0A64719AA788}"/>
             </a:ext>
           </a:extLst>
@@ -7333,7 +8407,7 @@
 </p:sld>
 </file>
 
-<file path=ppt/slides/slide8.xml><?xml version="1.0" encoding="utf-8"?>
+<file path=ppt/slides/slide9.xml><?xml version="1.0" encoding="utf-8"?>
 <p:sld xmlns:a="http://schemas.openxmlformats.org/drawingml/2006/main" xmlns:r="http://schemas.openxmlformats.org/officeDocument/2006/relationships" xmlns:p="http://schemas.openxmlformats.org/presentationml/2006/main">
   <p:cSld>
     <p:bg>
@@ -7859,420 +8933,6 @@
         <p14:creationId xmlns:p14="http://schemas.microsoft.com/office/powerpoint/2010/main" val="2272597280"/>
       </p:ext>
     </p:extLst>
-  </p:cSld>
-  <p:clrMapOvr>
-    <a:masterClrMapping/>
-  </p:clrMapOvr>
-</p:sld>
-</file>
-
-<file path=ppt/slides/slide9.xml><?xml version="1.0" encoding="utf-8"?>
-<p:sld xmlns:a="http://schemas.openxmlformats.org/drawingml/2006/main" xmlns:r="http://schemas.openxmlformats.org/officeDocument/2006/relationships" xmlns:p="http://schemas.openxmlformats.org/presentationml/2006/main" show="0">
-  <p:cSld name="Slide 8">
-    <p:bg>
-      <p:bgPr>
-        <a:solidFill>
-          <a:srgbClr val="1A2744"/>
-        </a:solidFill>
-        <a:effectLst/>
-      </p:bgPr>
-    </p:bg>
-    <p:spTree>
-      <p:nvGrpSpPr>
-        <p:cNvPr id="1" name=""/>
-        <p:cNvGrpSpPr/>
-        <p:nvPr/>
-      </p:nvGrpSpPr>
-      <p:grpSpPr>
-        <a:xfrm>
-          <a:off x="0" y="0"/>
-          <a:ext cx="0" cy="0"/>
-          <a:chOff x="0" y="0"/>
-          <a:chExt cx="0" cy="0"/>
-        </a:xfrm>
-      </p:grpSpPr>
-      <p:sp>
-        <p:nvSpPr>
-          <p:cNvPr id="2" name="Shape 0"/>
-          <p:cNvSpPr/>
-          <p:nvPr/>
-        </p:nvSpPr>
-        <p:spPr>
-          <a:xfrm>
-            <a:off x="0" y="0"/>
-            <a:ext cx="164592" cy="5143500"/>
-          </a:xfrm>
-          <a:prstGeom prst="rect">
-            <a:avLst/>
-          </a:prstGeom>
-          <a:solidFill>
-            <a:srgbClr val="00B4D8"/>
-          </a:solidFill>
-          <a:ln w="12700">
-            <a:solidFill>
-              <a:srgbClr val="00B4D8"/>
-            </a:solidFill>
-            <a:prstDash val="solid"/>
-          </a:ln>
-        </p:spPr>
-        <p:txBody>
-          <a:bodyPr/>
-          <a:lstStyle/>
-          <a:p>
-            <a:endParaRPr lang="it-CH"/>
-          </a:p>
-        </p:txBody>
-      </p:sp>
-      <p:sp>
-        <p:nvSpPr>
-          <p:cNvPr id="3" name="Text 1"/>
-          <p:cNvSpPr/>
-          <p:nvPr/>
-        </p:nvSpPr>
-        <p:spPr>
-          <a:xfrm>
-            <a:off x="365760" y="164592"/>
-            <a:ext cx="8412480" cy="548640"/>
-          </a:xfrm>
-          <a:prstGeom prst="rect">
-            <a:avLst/>
-          </a:prstGeom>
-          <a:noFill/>
-          <a:ln/>
-        </p:spPr>
-        <p:txBody>
-          <a:bodyPr wrap="square" lIns="0" tIns="0" rIns="0" bIns="0" rtlCol="0" anchor="ctr"/>
-          <a:lstStyle/>
-          <a:p>
-            <a:pPr marL="0" indent="0">
-              <a:buNone/>
-            </a:pPr>
-            <a:r>
-              <a:rPr lang="en-US" sz="2200" b="1" dirty="0">
-                <a:solidFill>
-                  <a:srgbClr val="00B4D8"/>
-                </a:solidFill>
-                <a:latin typeface="Calibri" pitchFamily="34" charset="0"/>
-                <a:ea typeface="Calibri" pitchFamily="34" charset="-122"/>
-                <a:cs typeface="Calibri" pitchFamily="34" charset="-120"/>
-              </a:rPr>
-              <a:t>Analisi Future Pianificate</a:t>
-            </a:r>
-            <a:endParaRPr lang="en-US" sz="2200" dirty="0"/>
-          </a:p>
-        </p:txBody>
-      </p:sp>
-      <p:sp>
-        <p:nvSpPr>
-          <p:cNvPr id="5" name="Shape 3"/>
-          <p:cNvSpPr/>
-          <p:nvPr/>
-        </p:nvSpPr>
-        <p:spPr>
-          <a:xfrm>
-            <a:off x="365760" y="838830"/>
-            <a:ext cx="8503920" cy="4007490"/>
-          </a:xfrm>
-          <a:prstGeom prst="rect">
-            <a:avLst/>
-          </a:prstGeom>
-          <a:solidFill>
-            <a:srgbClr val="1E3057"/>
-          </a:solidFill>
-          <a:ln w="12700">
-            <a:solidFill>
-              <a:srgbClr val="2A4580"/>
-            </a:solidFill>
-            <a:prstDash val="solid"/>
-          </a:ln>
-        </p:spPr>
-        <p:txBody>
-          <a:bodyPr/>
-          <a:lstStyle/>
-          <a:p>
-            <a:endParaRPr lang="it-CH"/>
-          </a:p>
-        </p:txBody>
-      </p:sp>
-      <p:sp>
-        <p:nvSpPr>
-          <p:cNvPr id="6" name="Text 4"/>
-          <p:cNvSpPr/>
-          <p:nvPr/>
-        </p:nvSpPr>
-        <p:spPr>
-          <a:xfrm>
-            <a:off x="365760" y="1234440"/>
-            <a:ext cx="8503920" cy="3611880"/>
-          </a:xfrm>
-          <a:prstGeom prst="rect">
-            <a:avLst/>
-          </a:prstGeom>
-          <a:noFill/>
-          <a:ln/>
-        </p:spPr>
-        <p:txBody>
-          <a:bodyPr wrap="square" lIns="0" tIns="0" rIns="0" bIns="0" rtlCol="0" anchor="ctr"/>
-          <a:lstStyle/>
-          <a:p>
-            <a:pPr marL="0" indent="0" algn="ctr">
-              <a:buNone/>
-            </a:pPr>
-            <a:endParaRPr lang="en-US" sz="1400" dirty="0"/>
-          </a:p>
-        </p:txBody>
-      </p:sp>
-      <p:sp>
-        <p:nvSpPr>
-          <p:cNvPr id="4" name="Text 2"/>
-          <p:cNvSpPr/>
-          <p:nvPr/>
-        </p:nvSpPr>
-        <p:spPr>
-          <a:xfrm>
-            <a:off x="687688" y="958740"/>
-            <a:ext cx="8181991" cy="3673715"/>
-          </a:xfrm>
-          <a:prstGeom prst="rect">
-            <a:avLst/>
-          </a:prstGeom>
-          <a:noFill/>
-          <a:ln/>
-        </p:spPr>
-        <p:txBody>
-          <a:bodyPr wrap="square" lIns="0" tIns="0" rIns="0" bIns="0" rtlCol="0" anchor="ctr"/>
-          <a:lstStyle/>
-          <a:p>
-            <a:pPr marL="342900" indent="-342900">
-              <a:buFont typeface="+mj-lt"/>
-              <a:buAutoNum type="arabicPeriod"/>
-            </a:pPr>
-            <a:r>
-              <a:rPr lang="en-US" sz="2400" i="1" dirty="0" err="1">
-                <a:solidFill>
-                  <a:srgbClr val="B0BEC5"/>
-                </a:solidFill>
-                <a:latin typeface="Calibri" pitchFamily="34" charset="0"/>
-                <a:ea typeface="Calibri" pitchFamily="34" charset="-122"/>
-                <a:cs typeface="Calibri" pitchFamily="34" charset="-120"/>
-              </a:rPr>
-              <a:t>Correlazione</a:t>
-            </a:r>
-            <a:r>
-              <a:rPr lang="en-US" sz="2400" i="1" dirty="0">
-                <a:solidFill>
-                  <a:srgbClr val="B0BEC5"/>
-                </a:solidFill>
-                <a:latin typeface="Calibri" pitchFamily="34" charset="0"/>
-                <a:ea typeface="Calibri" pitchFamily="34" charset="-122"/>
-                <a:cs typeface="Calibri" pitchFamily="34" charset="-120"/>
-              </a:rPr>
-              <a:t> </a:t>
-            </a:r>
-            <a:r>
-              <a:rPr lang="en-US" sz="2400" i="1" dirty="0" err="1">
-                <a:solidFill>
-                  <a:srgbClr val="B0BEC5"/>
-                </a:solidFill>
-                <a:latin typeface="Calibri" pitchFamily="34" charset="0"/>
-                <a:ea typeface="Calibri" pitchFamily="34" charset="-122"/>
-                <a:cs typeface="Calibri" pitchFamily="34" charset="-120"/>
-              </a:rPr>
-              <a:t>meteo</a:t>
-            </a:r>
-            <a:r>
-              <a:rPr lang="en-US" sz="2400" i="1" dirty="0">
-                <a:solidFill>
-                  <a:srgbClr val="B0BEC5"/>
-                </a:solidFill>
-                <a:latin typeface="Calibri" pitchFamily="34" charset="0"/>
-                <a:ea typeface="Calibri" pitchFamily="34" charset="-122"/>
-                <a:cs typeface="Calibri" pitchFamily="34" charset="-120"/>
-              </a:rPr>
-              <a:t> </a:t>
-            </a:r>
-          </a:p>
-          <a:p>
-            <a:pPr marL="342900" indent="-342900">
-              <a:buFont typeface="+mj-lt"/>
-              <a:buAutoNum type="arabicPeriod"/>
-            </a:pPr>
-            <a:r>
-              <a:rPr lang="en-US" sz="2400" i="1" dirty="0" err="1">
-                <a:solidFill>
-                  <a:srgbClr val="B0BEC5"/>
-                </a:solidFill>
-                <a:latin typeface="Calibri" pitchFamily="34" charset="0"/>
-                <a:ea typeface="Calibri" pitchFamily="34" charset="-122"/>
-                <a:cs typeface="Calibri" pitchFamily="34" charset="-120"/>
-              </a:rPr>
-              <a:t>Differenza</a:t>
-            </a:r>
-            <a:r>
-              <a:rPr lang="en-US" sz="2400" i="1" dirty="0">
-                <a:solidFill>
-                  <a:srgbClr val="B0BEC5"/>
-                </a:solidFill>
-                <a:latin typeface="Calibri" pitchFamily="34" charset="0"/>
-                <a:ea typeface="Calibri" pitchFamily="34" charset="-122"/>
-                <a:cs typeface="Calibri" pitchFamily="34" charset="-120"/>
-              </a:rPr>
-              <a:t> </a:t>
-            </a:r>
-            <a:r>
-              <a:rPr lang="en-US" sz="2400" i="1" dirty="0" err="1">
-                <a:solidFill>
-                  <a:srgbClr val="B0BEC5"/>
-                </a:solidFill>
-                <a:latin typeface="Calibri" pitchFamily="34" charset="0"/>
-                <a:ea typeface="Calibri" pitchFamily="34" charset="-122"/>
-                <a:cs typeface="Calibri" pitchFamily="34" charset="-120"/>
-              </a:rPr>
-              <a:t>velocità</a:t>
-            </a:r>
-            <a:r>
-              <a:rPr lang="en-US" sz="2400" i="1" dirty="0">
-                <a:solidFill>
-                  <a:srgbClr val="B0BEC5"/>
-                </a:solidFill>
-                <a:latin typeface="Calibri" pitchFamily="34" charset="0"/>
-                <a:ea typeface="Calibri" pitchFamily="34" charset="-122"/>
-                <a:cs typeface="Calibri" pitchFamily="34" charset="-120"/>
-              </a:rPr>
-              <a:t> – </a:t>
-            </a:r>
-            <a:r>
-              <a:rPr lang="en-US" sz="2400" i="1" dirty="0" err="1">
-                <a:solidFill>
-                  <a:srgbClr val="B0BEC5"/>
-                </a:solidFill>
-                <a:latin typeface="Calibri" pitchFamily="34" charset="0"/>
-                <a:ea typeface="Calibri" pitchFamily="34" charset="-122"/>
-                <a:cs typeface="Calibri" pitchFamily="34" charset="-120"/>
-              </a:rPr>
-              <a:t>tipo</a:t>
-            </a:r>
-            <a:r>
-              <a:rPr lang="en-US" sz="2400" i="1" dirty="0">
-                <a:solidFill>
-                  <a:srgbClr val="B0BEC5"/>
-                </a:solidFill>
-                <a:latin typeface="Calibri" pitchFamily="34" charset="0"/>
-                <a:ea typeface="Calibri" pitchFamily="34" charset="-122"/>
-                <a:cs typeface="Calibri" pitchFamily="34" charset="-120"/>
-              </a:rPr>
-              <a:t> di </a:t>
-            </a:r>
-            <a:r>
-              <a:rPr lang="en-US" sz="2400" i="1" dirty="0" err="1">
-                <a:solidFill>
-                  <a:srgbClr val="B0BEC5"/>
-                </a:solidFill>
-                <a:latin typeface="Calibri" pitchFamily="34" charset="0"/>
-                <a:ea typeface="Calibri" pitchFamily="34" charset="-122"/>
-                <a:cs typeface="Calibri" pitchFamily="34" charset="-120"/>
-              </a:rPr>
-              <a:t>veicolo</a:t>
-            </a:r>
-            <a:r>
-              <a:rPr lang="en-US" sz="2400" i="1" dirty="0">
-                <a:solidFill>
-                  <a:srgbClr val="B0BEC5"/>
-                </a:solidFill>
-                <a:latin typeface="Calibri" pitchFamily="34" charset="0"/>
-                <a:ea typeface="Calibri" pitchFamily="34" charset="-122"/>
-                <a:cs typeface="Calibri" pitchFamily="34" charset="-120"/>
-              </a:rPr>
-              <a:t> (moto/camion)</a:t>
-            </a:r>
-          </a:p>
-          <a:p>
-            <a:pPr marL="342900" indent="-342900">
-              <a:buFont typeface="+mj-lt"/>
-              <a:buAutoNum type="arabicPeriod"/>
-            </a:pPr>
-            <a:r>
-              <a:rPr lang="en-US" sz="2400" i="1" dirty="0" err="1">
-                <a:solidFill>
-                  <a:srgbClr val="B0BEC5"/>
-                </a:solidFill>
-                <a:latin typeface="Calibri" pitchFamily="34" charset="0"/>
-                <a:ea typeface="Calibri" pitchFamily="34" charset="-122"/>
-                <a:cs typeface="Calibri" pitchFamily="34" charset="-120"/>
-              </a:rPr>
-              <a:t>Differenza</a:t>
-            </a:r>
-            <a:r>
-              <a:rPr lang="en-US" sz="2400" i="1" dirty="0">
-                <a:solidFill>
-                  <a:srgbClr val="B0BEC5"/>
-                </a:solidFill>
-                <a:latin typeface="Calibri" pitchFamily="34" charset="0"/>
-                <a:ea typeface="Calibri" pitchFamily="34" charset="-122"/>
-                <a:cs typeface="Calibri" pitchFamily="34" charset="-120"/>
-              </a:rPr>
-              <a:t> </a:t>
-            </a:r>
-            <a:r>
-              <a:rPr lang="en-US" sz="2400" i="1" dirty="0" err="1">
-                <a:solidFill>
-                  <a:srgbClr val="B0BEC5"/>
-                </a:solidFill>
-                <a:latin typeface="Calibri" pitchFamily="34" charset="0"/>
-                <a:ea typeface="Calibri" pitchFamily="34" charset="-122"/>
-                <a:cs typeface="Calibri" pitchFamily="34" charset="-120"/>
-              </a:rPr>
-              <a:t>postazioni</a:t>
-            </a:r>
-            <a:r>
-              <a:rPr lang="en-US" sz="2400" i="1" dirty="0">
-                <a:solidFill>
-                  <a:srgbClr val="B0BEC5"/>
-                </a:solidFill>
-                <a:latin typeface="Calibri" pitchFamily="34" charset="0"/>
-                <a:ea typeface="Calibri" pitchFamily="34" charset="-122"/>
-                <a:cs typeface="Calibri" pitchFamily="34" charset="-120"/>
-              </a:rPr>
-              <a:t> radar Giorno-notte</a:t>
-            </a:r>
-          </a:p>
-          <a:p>
-            <a:pPr marL="342900" indent="-342900">
-              <a:buFont typeface="+mj-lt"/>
-              <a:buAutoNum type="arabicPeriod"/>
-            </a:pPr>
-            <a:r>
-              <a:rPr lang="en-US" sz="2400" i="1" dirty="0">
-                <a:solidFill>
-                  <a:srgbClr val="B0BEC5"/>
-                </a:solidFill>
-                <a:latin typeface="Calibri" pitchFamily="34" charset="0"/>
-                <a:ea typeface="Calibri" pitchFamily="34" charset="-122"/>
-                <a:cs typeface="Calibri" pitchFamily="34" charset="-120"/>
-              </a:rPr>
-              <a:t>…</a:t>
-            </a:r>
-          </a:p>
-          <a:p>
-            <a:pPr marL="342900" indent="-342900">
-              <a:buFont typeface="+mj-lt"/>
-              <a:buAutoNum type="arabicPeriod"/>
-            </a:pPr>
-            <a:r>
-              <a:rPr lang="en-US" sz="2400" i="1" dirty="0">
-                <a:solidFill>
-                  <a:srgbClr val="B0BEC5"/>
-                </a:solidFill>
-                <a:latin typeface="Calibri" pitchFamily="34" charset="0"/>
-                <a:ea typeface="Calibri" pitchFamily="34" charset="-122"/>
-                <a:cs typeface="Calibri" pitchFamily="34" charset="-120"/>
-              </a:rPr>
-              <a:t>Consigli?</a:t>
-            </a:r>
-          </a:p>
-        </p:txBody>
-      </p:sp>
-    </p:spTree>
   </p:cSld>
   <p:clrMapOvr>
     <a:masterClrMapping/>

</xml_diff>